<commit_message>
Align slide 8 question 4 with the power-study threshold
Question 4 still read "stays in single digits", which dated from when 9
events fell inside the production window. The card beside it now says 16,
so the two contradicted each other.

Changed to "stays well short of 45-75", the range already printed on that
same card, rather than the "~75" first suggested. ~75 is the six-lag-scan
threshold, but roadmap step 4 pre-registers the lag at k=3, which puts the
operative target near 48 -- so quoting 75 would cite the number from the
design the roadmap moves away from. The 45-75 range holds either way.

The matching speaker-note bullet is updated to the same wording. Layout is
unchanged: the question box stays at three lines and 80% full.

Co-Authored-By: Claude Opus 5 <noreply@anthropic.com>
</commit_message>
<xml_diff>
--- a/presentations/ev-investment-update.pptx
+++ b/presentations/ev-investment-update.pptx
@@ -2634,7 +2634,7 @@
 • The four questions are the real ask
 • Q2 (the inclusion rule) unblocks the most work — push for an answer on that
 • Q1 (a better capex feed) is highest value if the answer is yes
-• Fallback if events stay low: pre-register the lag, or pivot to the state panel</a:t>
+• Fallback if events stay well short of 45-75: pre-register the lag, or pivot to the state panel</a:t>
             </a:r>
             <a:endParaRPr lang="en-US" dirty="0"/>
           </a:p>
@@ -7914,7 +7914,7 @@
                 <a:ea typeface="Calibri" pitchFamily="34" charset="-122"/>
                 <a:cs typeface="Calibri" pitchFamily="34" charset="-120"/>
               </a:rPr>
-              <a:t>If the dated-event count stays in single digits, do you prefer an underpowered national test or a pivot to the state panel?</a:t>
+              <a:t>If the dated-event count stays well short of 45–75, do you prefer an underpowered national test or a pivot to the state panel?</a:t>
             </a:r>
             <a:endParaRPr lang="en-US" sz="1200" dirty="0"/>
           </a:p>

</xml_diff>

<commit_message>
Add AI design attribution to the final slide
Slide 8 now carries "Slide design and layout generated with Claude
(Anthropic Claude Code)" in the bottom-right, scoped to the design as
requested -- it makes no claim either way about the analysis or the
written content.

The existing closing line was narrowed from full width to 8.15in to make
room, so the two sit side by side on one baseline. Both end at y=6.92,
inside the 7.00in margin, and they do not overlap. The attribution reuses
the 8FB4AF already used beside it, which is 5.49:1 against the dark
background.

Co-Authored-By: Claude Opus 5 <noreply@anthropic.com>
</commit_message>
<xml_diff>
--- a/presentations/ev-investment-update.pptx
+++ b/presentations/ev-investment-update.pptx
@@ -7928,8 +7928,8 @@
         </p:nvSpPr>
         <p:spPr>
           <a:xfrm>
-            <a:off x="640080" y="5943600"/>
-            <a:ext cx="10881360" cy="365760"/>
+            <a:off x="640080" y="5907024"/>
+            <a:ext cx="7452360" cy="420624"/>
           </a:xfrm>
           <a:prstGeom prst="rect">
             <a:avLst/>
@@ -7956,6 +7956,45 @@
               <a:t>None of this blocks the stretch question — the state panel has 3,216 clean rows and reconciles exactly.</a:t>
             </a:r>
             <a:endParaRPr lang="en-US" sz="1200" dirty="0"/>
+          </a:p>
+        </p:txBody>
+      </p:sp>
+      <p:sp>
+        <p:nvSpPr>
+          <p:cNvPr id="18" name="Text 16"/>
+          <p:cNvSpPr txBox="1"/>
+          <p:nvPr/>
+        </p:nvSpPr>
+        <p:spPr>
+          <a:xfrm>
+            <a:off x="8183880" y="5907024"/>
+            <a:ext cx="3355848" cy="420624"/>
+          </a:xfrm>
+          <a:prstGeom prst="rect">
+            <a:avLst/>
+          </a:prstGeom>
+          <a:noFill/>
+          <a:ln/>
+        </p:spPr>
+        <p:txBody>
+          <a:bodyPr wrap="square" lIns="0" tIns="0" rIns="0" bIns="0" rtlCol="0" anchor="ctr"/>
+          <a:lstStyle/>
+          <a:p>
+            <a:pPr algn="r" indent="0" marL="0">
+              <a:buNone/>
+            </a:pPr>
+            <a:r>
+              <a:rPr lang="en-US" sz="950" dirty="0">
+                <a:solidFill>
+                  <a:srgbClr val="8FB4AF"/>
+                </a:solidFill>
+                <a:latin typeface="Calibri" pitchFamily="34" charset="0"/>
+                <a:ea typeface="Calibri" pitchFamily="34" charset="-122"/>
+                <a:cs typeface="Calibri" pitchFamily="34" charset="-120"/>
+              </a:rPr>
+              <a:t>Slide design and layout generated with Claude (Anthropic Claude Code)</a:t>
+            </a:r>
+            <a:endParaRPr lang="en-US" sz="950" dirty="0"/>
           </a:p>
         </p:txBody>
       </p:sp>

</xml_diff>

<commit_message>
Add attribution to the roadmap slide, align the backup one
Manual edits in PowerPoint:

- Copied the design attribution onto slide 6, the roadmap slide. That is
  the last slide actually presented, since slide 7 is backup and may never
  be shown, so the attribution now appears in the delivered flow rather
  than only behind a question.
- Widened the slide 7 attribution from 3.67in to 4.07in and moved it to
  x=8.55, which lines it up exactly with the questions panel above it.

Speaker notes and every other shape are unchanged. Committed as PowerPoint
saved it, so the file is byte-identical to what is being presented.

Co-Authored-By: Claude Opus 5 <noreply@anthropic.com>
</commit_message>
<xml_diff>
--- a/presentations/ev-investment-update.pptx
+++ b/presentations/ev-investment-update.pptx
@@ -4,6 +4,9 @@
   <p:sldMasterIdLst>
     <p:sldMasterId id="2147483648" r:id="rId1"/>
   </p:sldMasterIdLst>
+  <p:notesMasterIdLst>
+    <p:notesMasterId r:id="rId9"/>
+  </p:notesMasterIdLst>
   <p:sldIdLst>
     <p:sldId id="256" r:id="rId2"/>
     <p:sldId id="257" r:id="rId3"/>
@@ -13,9 +16,6 @@
     <p:sldId id="261" r:id="rId7"/>
     <p:sldId id="262" r:id="rId8"/>
   </p:sldIdLst>
-  <p:notesMasterIdLst>
-    <p:notesMasterId r:id="rId9"/>
-  </p:notesMasterIdLst>
   <p:sldSz cx="12192000" cy="6858000"/>
   <p:notesSz cx="6858000" cy="12192000"/>
   <p:defaultTextStyle>
@@ -110,18 +110,26 @@
       </a:defRPr>
     </a:lvl9pPr>
   </p:defaultTextStyle>
+  <p:extLst>
+    <p:ext uri="{EFAFB233-063F-42B5-8137-9DF3F51BA10A}">
+      <p15:sldGuideLst xmlns:p15="http://schemas.microsoft.com/office/powerpoint/2012/main"/>
+    </p:ext>
+  </p:extLst>
 </p:presentation>
 </file>
 
 <file path=ppt/charts/chart1.xml><?xml version="1.0" encoding="utf-8"?>
-<c:chartSpace xmlns:c="http://schemas.openxmlformats.org/drawingml/2006/chart" xmlns:a="http://schemas.openxmlformats.org/drawingml/2006/main" xmlns:r="http://schemas.openxmlformats.org/officeDocument/2006/relationships">
+<c:chartSpace xmlns:c="http://schemas.openxmlformats.org/drawingml/2006/chart" xmlns:a="http://schemas.openxmlformats.org/drawingml/2006/main" xmlns:r="http://schemas.openxmlformats.org/officeDocument/2006/relationships" xmlns:c16r2="http://schemas.microsoft.com/office/drawing/2015/06/chart">
   <c:date1904 val="0"/>
+  <c:lang val="en-US"/>
   <c:roundedCorners val="1"/>
+  <c:style val="2"/>
   <c:chart>
     <c:autoTitleDeleted val="1"/>
     <c:plotArea>
       <c:layout/>
       <c:lineChart>
+        <c:grouping val="standard"/>
         <c:varyColors val="0"/>
         <c:ser>
           <c:idx val="0"/>
@@ -138,9 +146,6 @@
             </c:strRef>
           </c:tx>
           <c:spPr>
-            <a:solidFill>
-              <a:srgbClr val="0D9488"/>
-            </a:solidFill>
             <a:ln w="38100" cap="flat">
               <a:solidFill>
                 <a:srgbClr val="0D9488"/>
@@ -150,31 +155,6 @@
             </a:ln>
             <a:effectLst/>
           </c:spPr>
-          <c:invertIfNegative val="0"/>
-          <c:dLbls>
-            <c:numFmt formatCode="#,##0" sourceLinked="0"/>
-            <c:txPr>
-              <a:bodyPr/>
-              <a:lstStyle/>
-              <a:p>
-                <a:pPr>
-                  <a:defRPr b="0" i="0" strike="noStrike" sz="1200" u="none">
-                    <a:solidFill>
-                      <a:srgbClr val="000000"/>
-                    </a:solidFill>
-                    <a:latin typeface="Arial"/>
-                  </a:defRPr>
-                </a:pPr>
-              </a:p>
-            </c:txPr>
-            <c:showLegendKey val="0"/>
-            <c:showVal val="0"/>
-            <c:showCatName val="0"/>
-            <c:showSerName val="0"/>
-            <c:showPercent val="0"/>
-            <c:showBubbleSize val="0"/>
-            <c:showLeaderLines val="0"/>
-          </c:dLbls>
           <c:marker>
             <c:symbol val="circle"/>
             <c:size val="6"/>
@@ -193,38 +173,36 @@
             </c:spPr>
           </c:marker>
           <c:cat>
-            <c:multiLvlStrRef>
+            <c:strRef>
               <c:f>Sheet1!$A$2:$A$9</c:f>
-              <c:multiLvlStrCache>
+              <c:strCache>
                 <c:ptCount val="8"/>
-                <c:lvl>
-                  <c:pt idx="0">
-                    <c:v>2018</c:v>
-                  </c:pt>
-                  <c:pt idx="1">
-                    <c:v>2019</c:v>
-                  </c:pt>
-                  <c:pt idx="2">
-                    <c:v>2020</c:v>
-                  </c:pt>
-                  <c:pt idx="3">
-                    <c:v>2021</c:v>
-                  </c:pt>
-                  <c:pt idx="4">
-                    <c:v>2022</c:v>
-                  </c:pt>
-                  <c:pt idx="5">
-                    <c:v>2023</c:v>
-                  </c:pt>
-                  <c:pt idx="6">
-                    <c:v>2024</c:v>
-                  </c:pt>
-                  <c:pt idx="7">
-                    <c:v>2025</c:v>
-                  </c:pt>
-                </c:lvl>
-              </c:multiLvlStrCache>
-            </c:multiLvlStrRef>
+                <c:pt idx="0">
+                  <c:v>2018</c:v>
+                </c:pt>
+                <c:pt idx="1">
+                  <c:v>2019</c:v>
+                </c:pt>
+                <c:pt idx="2">
+                  <c:v>2020</c:v>
+                </c:pt>
+                <c:pt idx="3">
+                  <c:v>2021</c:v>
+                </c:pt>
+                <c:pt idx="4">
+                  <c:v>2022</c:v>
+                </c:pt>
+                <c:pt idx="5">
+                  <c:v>2023</c:v>
+                </c:pt>
+                <c:pt idx="6">
+                  <c:v>2024</c:v>
+                </c:pt>
+                <c:pt idx="7">
+                  <c:v>2025</c:v>
+                </c:pt>
+              </c:strCache>
+            </c:strRef>
           </c:cat>
           <c:val>
             <c:numRef>
@@ -260,35 +238,24 @@
             </c:numRef>
           </c:val>
           <c:smooth val="0"/>
+          <c:extLst>
+            <c:ext xmlns:c16="http://schemas.microsoft.com/office/drawing/2014/chart" uri="{C3380CC4-5D6E-409C-BE32-E72D297353CC}">
+              <c16:uniqueId val="{00000000-BC00-2149-8C07-F82659B523A3}"/>
+            </c:ext>
+          </c:extLst>
         </c:ser>
         <c:dLbls>
-          <c:numFmt formatCode="#,##0" sourceLinked="0"/>
-          <c:txPr>
-            <a:bodyPr/>
-            <a:lstStyle/>
-            <a:p>
-              <a:pPr>
-                <a:defRPr b="0" i="0" strike="noStrike" sz="1200" u="none">
-                  <a:solidFill>
-                    <a:srgbClr val="000000"/>
-                  </a:solidFill>
-                  <a:latin typeface="Arial"/>
-                </a:defRPr>
-              </a:pPr>
-            </a:p>
-          </c:txPr>
           <c:showLegendKey val="0"/>
           <c:showVal val="0"/>
           <c:showCatName val="0"/>
           <c:showSerName val="0"/>
           <c:showPercent val="0"/>
           <c:showBubbleSize val="0"/>
-          <c:showLeaderLines val="0"/>
         </c:dLbls>
         <c:marker val="1"/>
+        <c:smooth val="0"/>
         <c:axId val="2094734554"/>
         <c:axId val="2094734552"/>
-        <c:axId val="2094734556"/>
       </c:lineChart>
       <c:catAx>
         <c:axId val="2094734554"/>
@@ -327,6 +294,7 @@
         <c:crosses val="autoZero"/>
         <c:auto val="1"/>
         <c:lblAlgn val="ctr"/>
+        <c:lblOffset val="100"/>
         <c:noMultiLvlLbl val="1"/>
       </c:catAx>
       <c:valAx>
@@ -388,6 +356,7 @@
     </c:plotArea>
     <c:plotVisOnly val="1"/>
     <c:dispBlanksAs val="span"/>
+    <c:showDLblsOverMax val="1"/>
   </c:chart>
   <c:spPr>
     <a:noFill/>
@@ -403,14 +372,17 @@
 </file>
 
 <file path=ppt/charts/chart2.xml><?xml version="1.0" encoding="utf-8"?>
-<c:chartSpace xmlns:c="http://schemas.openxmlformats.org/drawingml/2006/chart" xmlns:a="http://schemas.openxmlformats.org/drawingml/2006/main" xmlns:r="http://schemas.openxmlformats.org/officeDocument/2006/relationships">
+<c:chartSpace xmlns:c="http://schemas.openxmlformats.org/drawingml/2006/chart" xmlns:a="http://schemas.openxmlformats.org/drawingml/2006/main" xmlns:r="http://schemas.openxmlformats.org/officeDocument/2006/relationships" xmlns:c16r2="http://schemas.microsoft.com/office/drawing/2015/06/chart">
   <c:date1904 val="0"/>
+  <c:lang val="en-US"/>
   <c:roundedCorners val="1"/>
+  <c:style val="2"/>
   <c:chart>
     <c:autoTitleDeleted val="1"/>
     <c:plotArea>
       <c:layout/>
       <c:lineChart>
+        <c:grouping val="standard"/>
         <c:varyColors val="0"/>
         <c:ser>
           <c:idx val="0"/>
@@ -427,9 +399,6 @@
             </c:strRef>
           </c:tx>
           <c:spPr>
-            <a:solidFill>
-              <a:srgbClr val="0D9488"/>
-            </a:solidFill>
             <a:ln w="38100" cap="flat">
               <a:solidFill>
                 <a:srgbClr val="0D9488"/>
@@ -439,31 +408,6 @@
             </a:ln>
             <a:effectLst/>
           </c:spPr>
-          <c:invertIfNegative val="0"/>
-          <c:dLbls>
-            <c:numFmt formatCode="#,##0" sourceLinked="0"/>
-            <c:txPr>
-              <a:bodyPr/>
-              <a:lstStyle/>
-              <a:p>
-                <a:pPr>
-                  <a:defRPr b="0" i="0" strike="noStrike" sz="1200" u="none">
-                    <a:solidFill>
-                      <a:srgbClr val="000000"/>
-                    </a:solidFill>
-                    <a:latin typeface="Arial"/>
-                  </a:defRPr>
-                </a:pPr>
-              </a:p>
-            </c:txPr>
-            <c:showLegendKey val="0"/>
-            <c:showVal val="0"/>
-            <c:showCatName val="0"/>
-            <c:showSerName val="0"/>
-            <c:showPercent val="0"/>
-            <c:showBubbleSize val="0"/>
-            <c:showLeaderLines val="0"/>
-          </c:dLbls>
           <c:marker>
             <c:symbol val="circle"/>
             <c:size val="6"/>
@@ -482,38 +426,36 @@
             </c:spPr>
           </c:marker>
           <c:cat>
-            <c:multiLvlStrRef>
+            <c:strRef>
               <c:f>Sheet1!$A$2:$A$9</c:f>
-              <c:multiLvlStrCache>
+              <c:strCache>
                 <c:ptCount val="8"/>
-                <c:lvl>
-                  <c:pt idx="0">
-                    <c:v>16</c:v>
-                  </c:pt>
-                  <c:pt idx="1">
-                    <c:v>25</c:v>
-                  </c:pt>
-                  <c:pt idx="2">
-                    <c:v>35</c:v>
-                  </c:pt>
-                  <c:pt idx="3">
-                    <c:v>50</c:v>
-                  </c:pt>
-                  <c:pt idx="4">
-                    <c:v>65</c:v>
-                  </c:pt>
-                  <c:pt idx="5">
-                    <c:v>80</c:v>
-                  </c:pt>
-                  <c:pt idx="6">
-                    <c:v>100</c:v>
-                  </c:pt>
-                  <c:pt idx="7">
-                    <c:v>120</c:v>
-                  </c:pt>
-                </c:lvl>
-              </c:multiLvlStrCache>
-            </c:multiLvlStrRef>
+                <c:pt idx="0">
+                  <c:v>16</c:v>
+                </c:pt>
+                <c:pt idx="1">
+                  <c:v>25</c:v>
+                </c:pt>
+                <c:pt idx="2">
+                  <c:v>35</c:v>
+                </c:pt>
+                <c:pt idx="3">
+                  <c:v>50</c:v>
+                </c:pt>
+                <c:pt idx="4">
+                  <c:v>65</c:v>
+                </c:pt>
+                <c:pt idx="5">
+                  <c:v>80</c:v>
+                </c:pt>
+                <c:pt idx="6">
+                  <c:v>100</c:v>
+                </c:pt>
+                <c:pt idx="7">
+                  <c:v>120</c:v>
+                </c:pt>
+              </c:strCache>
+            </c:strRef>
           </c:cat>
           <c:val>
             <c:numRef>
@@ -549,6 +491,11 @@
             </c:numRef>
           </c:val>
           <c:smooth val="0"/>
+          <c:extLst>
+            <c:ext xmlns:c16="http://schemas.microsoft.com/office/drawing/2014/chart" uri="{C3380CC4-5D6E-409C-BE32-E72D297353CC}">
+              <c16:uniqueId val="{00000000-482E-F34D-A216-78E38D56F3FB}"/>
+            </c:ext>
+          </c:extLst>
         </c:ser>
         <c:ser>
           <c:idx val="1"/>
@@ -565,9 +512,6 @@
             </c:strRef>
           </c:tx>
           <c:spPr>
-            <a:solidFill>
-              <a:srgbClr val="D94F04"/>
-            </a:solidFill>
             <a:ln w="38100" cap="flat">
               <a:solidFill>
                 <a:srgbClr val="D94F04"/>
@@ -577,31 +521,6 @@
             </a:ln>
             <a:effectLst/>
           </c:spPr>
-          <c:invertIfNegative val="0"/>
-          <c:dLbls>
-            <c:numFmt formatCode="#,##0" sourceLinked="0"/>
-            <c:txPr>
-              <a:bodyPr/>
-              <a:lstStyle/>
-              <a:p>
-                <a:pPr>
-                  <a:defRPr b="0" i="0" strike="noStrike" sz="1200" u="none">
-                    <a:solidFill>
-                      <a:srgbClr val="000000"/>
-                    </a:solidFill>
-                    <a:latin typeface="Arial"/>
-                  </a:defRPr>
-                </a:pPr>
-              </a:p>
-            </c:txPr>
-            <c:showLegendKey val="0"/>
-            <c:showVal val="0"/>
-            <c:showCatName val="0"/>
-            <c:showSerName val="0"/>
-            <c:showPercent val="0"/>
-            <c:showBubbleSize val="0"/>
-            <c:showLeaderLines val="0"/>
-          </c:dLbls>
           <c:marker>
             <c:symbol val="circle"/>
             <c:size val="6"/>
@@ -620,38 +539,36 @@
             </c:spPr>
           </c:marker>
           <c:cat>
-            <c:multiLvlStrRef>
+            <c:strRef>
               <c:f>Sheet1!$A$2:$A$9</c:f>
-              <c:multiLvlStrCache>
+              <c:strCache>
                 <c:ptCount val="8"/>
-                <c:lvl>
-                  <c:pt idx="0">
-                    <c:v>16</c:v>
-                  </c:pt>
-                  <c:pt idx="1">
-                    <c:v>25</c:v>
-                  </c:pt>
-                  <c:pt idx="2">
-                    <c:v>35</c:v>
-                  </c:pt>
-                  <c:pt idx="3">
-                    <c:v>50</c:v>
-                  </c:pt>
-                  <c:pt idx="4">
-                    <c:v>65</c:v>
-                  </c:pt>
-                  <c:pt idx="5">
-                    <c:v>80</c:v>
-                  </c:pt>
-                  <c:pt idx="6">
-                    <c:v>100</c:v>
-                  </c:pt>
-                  <c:pt idx="7">
-                    <c:v>120</c:v>
-                  </c:pt>
-                </c:lvl>
-              </c:multiLvlStrCache>
-            </c:multiLvlStrRef>
+                <c:pt idx="0">
+                  <c:v>16</c:v>
+                </c:pt>
+                <c:pt idx="1">
+                  <c:v>25</c:v>
+                </c:pt>
+                <c:pt idx="2">
+                  <c:v>35</c:v>
+                </c:pt>
+                <c:pt idx="3">
+                  <c:v>50</c:v>
+                </c:pt>
+                <c:pt idx="4">
+                  <c:v>65</c:v>
+                </c:pt>
+                <c:pt idx="5">
+                  <c:v>80</c:v>
+                </c:pt>
+                <c:pt idx="6">
+                  <c:v>100</c:v>
+                </c:pt>
+                <c:pt idx="7">
+                  <c:v>120</c:v>
+                </c:pt>
+              </c:strCache>
+            </c:strRef>
           </c:cat>
           <c:val>
             <c:numRef>
@@ -687,6 +604,11 @@
             </c:numRef>
           </c:val>
           <c:smooth val="0"/>
+          <c:extLst>
+            <c:ext xmlns:c16="http://schemas.microsoft.com/office/drawing/2014/chart" uri="{C3380CC4-5D6E-409C-BE32-E72D297353CC}">
+              <c16:uniqueId val="{00000001-482E-F34D-A216-78E38D56F3FB}"/>
+            </c:ext>
+          </c:extLst>
         </c:ser>
         <c:ser>
           <c:idx val="2"/>
@@ -703,9 +625,6 @@
             </c:strRef>
           </c:tx>
           <c:spPr>
-            <a:solidFill>
-              <a:srgbClr val="7048C4"/>
-            </a:solidFill>
             <a:ln w="38100" cap="flat">
               <a:solidFill>
                 <a:srgbClr val="7048C4"/>
@@ -715,31 +634,6 @@
             </a:ln>
             <a:effectLst/>
           </c:spPr>
-          <c:invertIfNegative val="0"/>
-          <c:dLbls>
-            <c:numFmt formatCode="#,##0" sourceLinked="0"/>
-            <c:txPr>
-              <a:bodyPr/>
-              <a:lstStyle/>
-              <a:p>
-                <a:pPr>
-                  <a:defRPr b="0" i="0" strike="noStrike" sz="1200" u="none">
-                    <a:solidFill>
-                      <a:srgbClr val="000000"/>
-                    </a:solidFill>
-                    <a:latin typeface="Arial"/>
-                  </a:defRPr>
-                </a:pPr>
-              </a:p>
-            </c:txPr>
-            <c:showLegendKey val="0"/>
-            <c:showVal val="0"/>
-            <c:showCatName val="0"/>
-            <c:showSerName val="0"/>
-            <c:showPercent val="0"/>
-            <c:showBubbleSize val="0"/>
-            <c:showLeaderLines val="0"/>
-          </c:dLbls>
           <c:marker>
             <c:symbol val="circle"/>
             <c:size val="6"/>
@@ -758,38 +652,36 @@
             </c:spPr>
           </c:marker>
           <c:cat>
-            <c:multiLvlStrRef>
+            <c:strRef>
               <c:f>Sheet1!$A$2:$A$9</c:f>
-              <c:multiLvlStrCache>
+              <c:strCache>
                 <c:ptCount val="8"/>
-                <c:lvl>
-                  <c:pt idx="0">
-                    <c:v>16</c:v>
-                  </c:pt>
-                  <c:pt idx="1">
-                    <c:v>25</c:v>
-                  </c:pt>
-                  <c:pt idx="2">
-                    <c:v>35</c:v>
-                  </c:pt>
-                  <c:pt idx="3">
-                    <c:v>50</c:v>
-                  </c:pt>
-                  <c:pt idx="4">
-                    <c:v>65</c:v>
-                  </c:pt>
-                  <c:pt idx="5">
-                    <c:v>80</c:v>
-                  </c:pt>
-                  <c:pt idx="6">
-                    <c:v>100</c:v>
-                  </c:pt>
-                  <c:pt idx="7">
-                    <c:v>120</c:v>
-                  </c:pt>
-                </c:lvl>
-              </c:multiLvlStrCache>
-            </c:multiLvlStrRef>
+                <c:pt idx="0">
+                  <c:v>16</c:v>
+                </c:pt>
+                <c:pt idx="1">
+                  <c:v>25</c:v>
+                </c:pt>
+                <c:pt idx="2">
+                  <c:v>35</c:v>
+                </c:pt>
+                <c:pt idx="3">
+                  <c:v>50</c:v>
+                </c:pt>
+                <c:pt idx="4">
+                  <c:v>65</c:v>
+                </c:pt>
+                <c:pt idx="5">
+                  <c:v>80</c:v>
+                </c:pt>
+                <c:pt idx="6">
+                  <c:v>100</c:v>
+                </c:pt>
+                <c:pt idx="7">
+                  <c:v>120</c:v>
+                </c:pt>
+              </c:strCache>
+            </c:strRef>
           </c:cat>
           <c:val>
             <c:numRef>
@@ -825,35 +717,24 @@
             </c:numRef>
           </c:val>
           <c:smooth val="0"/>
+          <c:extLst>
+            <c:ext xmlns:c16="http://schemas.microsoft.com/office/drawing/2014/chart" uri="{C3380CC4-5D6E-409C-BE32-E72D297353CC}">
+              <c16:uniqueId val="{00000002-482E-F34D-A216-78E38D56F3FB}"/>
+            </c:ext>
+          </c:extLst>
         </c:ser>
         <c:dLbls>
-          <c:numFmt formatCode="#,##0" sourceLinked="0"/>
-          <c:txPr>
-            <a:bodyPr/>
-            <a:lstStyle/>
-            <a:p>
-              <a:pPr>
-                <a:defRPr b="0" i="0" strike="noStrike" sz="1200" u="none">
-                  <a:solidFill>
-                    <a:srgbClr val="000000"/>
-                  </a:solidFill>
-                  <a:latin typeface="Arial"/>
-                </a:defRPr>
-              </a:pPr>
-            </a:p>
-          </c:txPr>
           <c:showLegendKey val="0"/>
           <c:showVal val="0"/>
           <c:showCatName val="0"/>
           <c:showSerName val="0"/>
           <c:showPercent val="0"/>
           <c:showBubbleSize val="0"/>
-          <c:showLeaderLines val="0"/>
         </c:dLbls>
         <c:marker val="1"/>
+        <c:smooth val="0"/>
         <c:axId val="2094734554"/>
         <c:axId val="2094734552"/>
-        <c:axId val="2094734556"/>
       </c:lineChart>
       <c:catAx>
         <c:axId val="2094734554"/>
@@ -892,6 +773,7 @@
         <c:crosses val="autoZero"/>
         <c:auto val="1"/>
         <c:lblAlgn val="ctr"/>
+        <c:lblOffset val="100"/>
         <c:noMultiLvlLbl val="1"/>
       </c:catAx>
       <c:valAx>
@@ -974,6 +856,7 @@
     </c:legend>
     <c:plotVisOnly val="1"/>
     <c:dispBlanksAs val="span"/>
+    <c:showDLblsOverMax val="1"/>
   </c:chart>
   <c:spPr>
     <a:noFill/>
@@ -1010,234 +893,10 @@
           <a:chExt cx="0" cy="0"/>
         </a:xfrm>
       </p:grpSpPr>
-      <p:sp>
-        <p:nvSpPr>
-          <p:cNvPr id="2" name="Header Placeholder 1"/>
-          <p:cNvSpPr>
-            <a:spLocks noGrp="1"/>
-          </p:cNvSpPr>
-          <p:nvPr>
-            <p:ph type="hdr" sz="quarter"/>
-          </p:nvPr>
-        </p:nvSpPr>
-        <p:spPr>
-          <a:xfrm>
-            <a:off x="0" y="0"/>
-            <a:ext cx="2971800" cy="458788"/>
-          </a:xfrm>
-          <a:prstGeom prst="rect">
-            <a:avLst/>
-          </a:prstGeom>
-        </p:spPr>
-        <p:txBody>
-          <a:bodyPr vert="horz" lIns="91440" tIns="45720" rIns="91440" bIns="45720" rtlCol="0"/>
-          <a:lstStyle>
-            <a:lvl1pPr algn="l">
-              <a:defRPr sz="1200"/>
-            </a:lvl1pPr>
-          </a:lstStyle>
-          <a:p>
-            <a:endParaRPr lang="en-US"/>
-          </a:p>
-        </p:txBody>
-      </p:sp>
-      <p:sp>
-        <p:nvSpPr>
-          <p:cNvPr id="3" name="Date Placeholder 2"/>
-          <p:cNvSpPr>
-            <a:spLocks noGrp="1"/>
-          </p:cNvSpPr>
-          <p:nvPr>
-            <p:ph type="dt" idx="1"/>
-          </p:nvPr>
-        </p:nvSpPr>
-        <p:spPr>
-          <a:xfrm>
-            <a:off x="3884613" y="0"/>
-            <a:ext cx="2971800" cy="458788"/>
-          </a:xfrm>
-          <a:prstGeom prst="rect">
-            <a:avLst/>
-          </a:prstGeom>
-        </p:spPr>
-        <p:txBody>
-          <a:bodyPr vert="horz" lIns="91440" tIns="45720" rIns="91440" bIns="45720" rtlCol="0"/>
-          <a:lstStyle>
-            <a:lvl1pPr algn="r">
-              <a:defRPr sz="1200"/>
-            </a:lvl1pPr>
-          </a:lstStyle>
-          <a:p>
-            <a:fld id="{5282F153-3F37-0F45-9E97-73ACFA13230C}" type="datetimeFigureOut">
-              <a:rPr lang="en-US"/>
-              <a:t>7/23/19</a:t>
-            </a:fld>
-            <a:endParaRPr lang="en-US"/>
-          </a:p>
-        </p:txBody>
-      </p:sp>
-      <p:sp>
-        <p:nvSpPr>
-          <p:cNvPr id="4" name="Slide Image Placeholder 3"/>
-          <p:cNvSpPr>
-            <a:spLocks noGrp="1" noRot="1" noChangeAspect="1"/>
-          </p:cNvSpPr>
-          <p:nvPr>
-            <p:ph type="sldImg" idx="2"/>
-          </p:nvPr>
-        </p:nvSpPr>
-        <p:spPr>
-          <a:xfrm>
-            <a:off x="685800" y="1143000"/>
-            <a:ext cx="5486400" cy="3086100"/>
-          </a:xfrm>
-          <a:prstGeom prst="rect">
-            <a:avLst/>
-          </a:prstGeom>
-          <a:noFill/>
-          <a:ln w="12700">
-            <a:solidFill>
-              <a:prstClr val="black"/>
-            </a:solidFill>
-          </a:ln>
-        </p:spPr>
-        <p:txBody>
-          <a:bodyPr vert="horz" lIns="91440" tIns="45720" rIns="91440" bIns="45720" rtlCol="0" anchor="ctr"/>
-          <a:lstStyle/>
-          <a:p>
-            <a:endParaRPr lang="en-US"/>
-          </a:p>
-        </p:txBody>
-      </p:sp>
-      <p:sp>
-        <p:nvSpPr>
-          <p:cNvPr id="5" name="Notes Placeholder 4"/>
-          <p:cNvSpPr>
-            <a:spLocks noGrp="1"/>
-          </p:cNvSpPr>
-          <p:nvPr>
-            <p:ph type="body" sz="quarter" idx="3"/>
-          </p:nvPr>
-        </p:nvSpPr>
-        <p:spPr>
-          <a:xfrm>
-            <a:off x="685800" y="4400550"/>
-            <a:ext cx="5486400" cy="3600450"/>
-          </a:xfrm>
-          <a:prstGeom prst="rect">
-            <a:avLst/>
-          </a:prstGeom>
-        </p:spPr>
-        <p:txBody>
-          <a:bodyPr vert="horz" lIns="91440" tIns="45720" rIns="91440" bIns="45720" rtlCol="0"/>
-          <a:lstStyle/>
-          <a:p>
-            <a:pPr lvl="0"/>
-            <a:r>
-              <a:rPr lang="en-US"/>
-              <a:t>Click to edit Master text styles</a:t>
-            </a:r>
-          </a:p>
-          <a:p>
-            <a:pPr lvl="1"/>
-            <a:r>
-              <a:rPr lang="en-US"/>
-              <a:t>Second level</a:t>
-            </a:r>
-          </a:p>
-          <a:p>
-            <a:pPr lvl="2"/>
-            <a:r>
-              <a:rPr lang="en-US"/>
-              <a:t>Third level</a:t>
-            </a:r>
-          </a:p>
-          <a:p>
-            <a:pPr lvl="3"/>
-            <a:r>
-              <a:rPr lang="en-US"/>
-              <a:t>Fourth level</a:t>
-            </a:r>
-          </a:p>
-          <a:p>
-            <a:pPr lvl="4"/>
-            <a:r>
-              <a:rPr lang="en-US"/>
-              <a:t>Fifth level</a:t>
-            </a:r>
-          </a:p>
-        </p:txBody>
-      </p:sp>
-      <p:sp>
-        <p:nvSpPr>
-          <p:cNvPr id="6" name="Footer Placeholder 5"/>
-          <p:cNvSpPr>
-            <a:spLocks noGrp="1"/>
-          </p:cNvSpPr>
-          <p:nvPr>
-            <p:ph type="ftr" sz="quarter" idx="4"/>
-          </p:nvPr>
-        </p:nvSpPr>
-        <p:spPr>
-          <a:xfrm>
-            <a:off x="0" y="8685213"/>
-            <a:ext cx="2971800" cy="458787"/>
-          </a:xfrm>
-          <a:prstGeom prst="rect">
-            <a:avLst/>
-          </a:prstGeom>
-        </p:spPr>
-        <p:txBody>
-          <a:bodyPr vert="horz" lIns="91440" tIns="45720" rIns="91440" bIns="45720" rtlCol="0" anchor="b"/>
-          <a:lstStyle>
-            <a:lvl1pPr algn="l">
-              <a:defRPr sz="1200"/>
-            </a:lvl1pPr>
-          </a:lstStyle>
-          <a:p>
-            <a:endParaRPr lang="en-US"/>
-          </a:p>
-        </p:txBody>
-      </p:sp>
-      <p:sp>
-        <p:nvSpPr>
-          <p:cNvPr id="7" name="Slide Number Placeholder 6"/>
-          <p:cNvSpPr>
-            <a:spLocks noGrp="1"/>
-          </p:cNvSpPr>
-          <p:nvPr>
-            <p:ph type="sldNum" sz="quarter" idx="5"/>
-          </p:nvPr>
-        </p:nvSpPr>
-        <p:spPr>
-          <a:xfrm>
-            <a:off x="3884613" y="8685213"/>
-            <a:ext cx="2971800" cy="458787"/>
-          </a:xfrm>
-          <a:prstGeom prst="rect">
-            <a:avLst/>
-          </a:prstGeom>
-        </p:spPr>
-        <p:txBody>
-          <a:bodyPr vert="horz" lIns="91440" tIns="45720" rIns="91440" bIns="45720" rtlCol="0" anchor="b"/>
-          <a:lstStyle>
-            <a:lvl1pPr algn="r">
-              <a:defRPr sz="1200"/>
-            </a:lvl1pPr>
-          </a:lstStyle>
-          <a:p>
-            <a:fld id="{CE5E9CC1-C706-0F49-92D6-E571CC5EEA8F}" type="slidenum">
-              <a:rPr lang="en-US"/>
-              <a:t>‹#›</a:t>
-            </a:fld>
-            <a:endParaRPr lang="en-US"/>
-          </a:p>
-        </p:txBody>
-      </p:sp>
     </p:spTree>
     <p:extLst>
       <p:ext uri="{BB962C8B-B14F-4D97-AF65-F5344CB8AC3E}">
-        <p14:creationId xmlns:p14="http://schemas.microsoft.com/office/powerpoint/2010/main" val="1024086991"/>
+        <p14:creationId xmlns:p14="http://schemas.microsoft.com/office/powerpoint/2010/main" val="2179530821"/>
       </p:ext>
     </p:extLst>
   </p:cSld>
@@ -1389,7 +1048,6 @@
 • Two parts: national (primary), state siting (stretch)
 • All data via the Thurro connector, India only</a:t>
             </a:r>
-            <a:endParaRPr lang="en-US" dirty="0"/>
           </a:p>
         </p:txBody>
       </p:sp>
@@ -1483,7 +1141,6 @@
 • Honest caveat: siting may be incentive-driven, as the US IRA wave suggests
 • So the project does not fail if the stretch answer is that incentives decide</a:t>
             </a:r>
-            <a:endParaRPr lang="en-US" dirty="0"/>
           </a:p>
         </p:txBody>
       </p:sp>
@@ -1577,7 +1234,6 @@
 • Do not read the orange detail aloud — point at it, defer to the backup slide
 • Substitute: 34 events hand-coded from exchange filings</a:t>
             </a:r>
-            <a:endParaRPr lang="en-US" dirty="0"/>
           </a:p>
         </p:txBody>
       </p:sp>
@@ -1674,7 +1330,6 @@
 • Lead test: +0.24 at k=0, -0.20 at k=1, +0.40 at k=2, n=39 — say plainly that is noise
 • Cut for time: the production-coverage chart (27% to 60%) — raise it only if asked</a:t>
             </a:r>
-            <a:endParaRPr lang="en-US" dirty="0"/>
           </a:p>
         </p:txBody>
       </p:sp>
@@ -1773,7 +1428,6 @@
 • Say it plainly — that is not evidence of no lead, it is an underpowered test
 • If asked: false-positive rate checks out at 1.5-2.5%, solver validated against statsmodels</a:t>
             </a:r>
-            <a:endParaRPr lang="en-US" dirty="0"/>
           </a:p>
         </p:txBody>
       </p:sp>
@@ -1868,7 +1522,6 @@
 • Step 5: write up, including the negative result on the investment source
 • Close on this: the modelling is not the risk, the dependent variable is</a:t>
             </a:r>
-            <a:endParaRPr lang="en-US" dirty="0"/>
           </a:p>
         </p:txBody>
       </p:sp>
@@ -1963,7 +1616,6 @@
 • Q1 (a better capex feed) is highest value if the answer is yes
 • Fallback if events stay well short of 45-75: pre-register the lag, or pivot to the state panel</a:t>
             </a:r>
-            <a:endParaRPr lang="en-US" dirty="0"/>
           </a:p>
         </p:txBody>
       </p:sp>
@@ -2036,6 +1688,11 @@
 <file path=ppt/slideMasters/slideMaster1.xml><?xml version="1.0" encoding="utf-8"?>
 <p:sldMaster xmlns:a="http://schemas.openxmlformats.org/drawingml/2006/main" xmlns:r="http://schemas.openxmlformats.org/officeDocument/2006/relationships" xmlns:p="http://schemas.openxmlformats.org/presentationml/2006/main">
   <p:cSld>
+    <p:bg>
+      <p:bgRef idx="1001">
+        <a:schemeClr val="bg1"/>
+      </p:bgRef>
+    </p:bg>
     <p:spTree>
       <p:nvGrpSpPr>
         <p:cNvPr id="1" name=""/>
@@ -2318,6 +1975,7 @@
         <a:solidFill>
           <a:srgbClr val="0B3B38"/>
         </a:solidFill>
+        <a:effectLst/>
       </p:bgPr>
     </p:bg>
     <p:spTree>
@@ -2358,6 +2016,13 @@
             <a:prstDash val="solid"/>
           </a:ln>
         </p:spPr>
+        <p:txBody>
+          <a:bodyPr/>
+          <a:lstStyle/>
+          <a:p>
+            <a:endParaRPr lang="en-US"/>
+          </a:p>
+        </p:txBody>
       </p:sp>
       <p:sp>
         <p:nvSpPr>
@@ -2383,6 +2048,13 @@
             <a:prstDash val="solid"/>
           </a:ln>
         </p:spPr>
+        <p:txBody>
+          <a:bodyPr/>
+          <a:lstStyle/>
+          <a:p>
+            <a:endParaRPr lang="en-US"/>
+          </a:p>
+        </p:txBody>
       </p:sp>
       <p:sp>
         <p:nvSpPr>
@@ -2405,11 +2077,11 @@
           <a:bodyPr wrap="square" lIns="0" tIns="0" rIns="0" bIns="0" rtlCol="0" anchor="ctr"/>
           <a:lstStyle/>
           <a:p>
-            <a:pPr indent="0" marL="0">
-              <a:buNone/>
-            </a:pPr>
-            <a:r>
-              <a:rPr lang="en-US" sz="1200" b="1" spc="180" kern="0" dirty="0">
+            <a:pPr marL="0" indent="0">
+              <a:buNone/>
+            </a:pPr>
+            <a:r>
+              <a:rPr lang="en-US" sz="1200" b="1" kern="0" spc="180" dirty="0">
                 <a:solidFill>
                   <a:srgbClr val="6FD8CB"/>
                 </a:solidFill>
@@ -2444,7 +2116,7 @@
           <a:bodyPr wrap="square" lIns="0" tIns="0" rIns="0" bIns="0" rtlCol="0" anchor="ctr"/>
           <a:lstStyle/>
           <a:p>
-            <a:pPr indent="0" marL="0">
+            <a:pPr marL="0" indent="0">
               <a:lnSpc>
                 <a:spcPts val="5200"/>
               </a:lnSpc>
@@ -2464,7 +2136,7 @@
             <a:endParaRPr lang="en-US" sz="4600" dirty="0"/>
           </a:p>
           <a:p>
-            <a:pPr indent="0" marL="0">
+            <a:pPr marL="0" indent="0">
               <a:lnSpc>
                 <a:spcPts val="5200"/>
               </a:lnSpc>
@@ -2506,7 +2178,7 @@
           <a:bodyPr wrap="square" lIns="0" tIns="0" rIns="0" bIns="0" rtlCol="0" anchor="ctr"/>
           <a:lstStyle/>
           <a:p>
-            <a:pPr indent="0" marL="0">
+            <a:pPr marL="0" indent="0">
               <a:buNone/>
             </a:pPr>
             <a:r>
@@ -2545,7 +2217,7 @@
           <a:bodyPr wrap="square" lIns="0" tIns="0" rIns="0" bIns="0" rtlCol="0" anchor="ctr"/>
           <a:lstStyle/>
           <a:p>
-            <a:pPr indent="0" marL="0">
+            <a:pPr marL="0" indent="0">
               <a:buNone/>
             </a:pPr>
             <a:r>
@@ -2579,6 +2251,7 @@
         <a:solidFill>
           <a:srgbClr val="FFFFFF"/>
         </a:solidFill>
+        <a:effectLst/>
       </p:bgPr>
     </p:bg>
     <p:spTree>
@@ -2616,11 +2289,11 @@
           <a:bodyPr wrap="square" lIns="0" tIns="0" rIns="0" bIns="0" rtlCol="0" anchor="ctr"/>
           <a:lstStyle/>
           <a:p>
-            <a:pPr indent="0" marL="0">
-              <a:buNone/>
-            </a:pPr>
-            <a:r>
-              <a:rPr lang="en-US" sz="1200" b="1" spc="160" kern="0" dirty="0">
+            <a:pPr marL="0" indent="0">
+              <a:buNone/>
+            </a:pPr>
+            <a:r>
+              <a:rPr lang="en-US" sz="1200" b="1" kern="0" spc="160" dirty="0">
                 <a:solidFill>
                   <a:srgbClr val="0D9488"/>
                 </a:solidFill>
@@ -2655,7 +2328,7 @@
           <a:bodyPr wrap="square" lIns="0" tIns="0" rIns="0" bIns="0" rtlCol="0" anchor="ctr"/>
           <a:lstStyle/>
           <a:p>
-            <a:pPr indent="0" marL="0">
+            <a:pPr marL="0" indent="0">
               <a:buNone/>
             </a:pPr>
             <a:r>
@@ -2694,7 +2367,7 @@
           <a:bodyPr wrap="square" lIns="0" tIns="0" rIns="0" bIns="0" rtlCol="0" anchor="ctr"/>
           <a:lstStyle/>
           <a:p>
-            <a:pPr indent="0" marL="0">
+            <a:pPr marL="0" indent="0">
               <a:buNone/>
             </a:pPr>
             <a:r>
@@ -2738,6 +2411,13 @@
             <a:prstDash val="solid"/>
           </a:ln>
         </p:spPr>
+        <p:txBody>
+          <a:bodyPr/>
+          <a:lstStyle/>
+          <a:p>
+            <a:endParaRPr lang="en-US"/>
+          </a:p>
+        </p:txBody>
       </p:sp>
       <p:sp>
         <p:nvSpPr>
@@ -2763,6 +2443,13 @@
             <a:prstDash val="solid"/>
           </a:ln>
         </p:spPr>
+        <p:txBody>
+          <a:bodyPr/>
+          <a:lstStyle/>
+          <a:p>
+            <a:endParaRPr lang="en-US"/>
+          </a:p>
+        </p:txBody>
       </p:sp>
       <p:sp>
         <p:nvSpPr>
@@ -2785,11 +2472,11 @@
           <a:bodyPr wrap="square" lIns="0" tIns="0" rIns="0" bIns="0" rtlCol="0" anchor="ctr"/>
           <a:lstStyle/>
           <a:p>
-            <a:pPr indent="0" marL="0">
-              <a:buNone/>
-            </a:pPr>
-            <a:r>
-              <a:rPr lang="en-US" sz="1100" b="1" spc="140" kern="0" dirty="0">
+            <a:pPr marL="0" indent="0">
+              <a:buNone/>
+            </a:pPr>
+            <a:r>
+              <a:rPr lang="en-US" sz="1100" b="1" kern="0" spc="140" dirty="0">
                 <a:solidFill>
                   <a:srgbClr val="0D9488"/>
                 </a:solidFill>
@@ -2824,7 +2511,7 @@
           <a:bodyPr wrap="square" lIns="0" tIns="0" rIns="0" bIns="0" rtlCol="0" anchor="ctr"/>
           <a:lstStyle/>
           <a:p>
-            <a:pPr algn="r" indent="0" marL="0">
+            <a:pPr marL="0" indent="0" algn="r">
               <a:buNone/>
             </a:pPr>
             <a:r>
@@ -2863,7 +2550,7 @@
           <a:bodyPr wrap="square" lIns="0" tIns="0" rIns="0" bIns="0" rtlCol="0" anchor="ctr"/>
           <a:lstStyle/>
           <a:p>
-            <a:pPr indent="0" marL="0">
+            <a:pPr marL="0" indent="0">
               <a:buNone/>
             </a:pPr>
             <a:r>
@@ -2902,7 +2589,7 @@
           <a:bodyPr wrap="square" lIns="0" tIns="0" rIns="0" bIns="0" rtlCol="0" anchor="ctr"/>
           <a:lstStyle/>
           <a:p>
-            <a:pPr indent="0" marL="0">
+            <a:pPr marL="0" indent="0">
               <a:buNone/>
             </a:pPr>
             <a:r>
@@ -2946,6 +2633,13 @@
             <a:prstDash val="solid"/>
           </a:ln>
         </p:spPr>
+        <p:txBody>
+          <a:bodyPr/>
+          <a:lstStyle/>
+          <a:p>
+            <a:endParaRPr lang="en-US"/>
+          </a:p>
+        </p:txBody>
       </p:sp>
       <p:sp>
         <p:nvSpPr>
@@ -2971,6 +2665,13 @@
             <a:prstDash val="solid"/>
           </a:ln>
         </p:spPr>
+        <p:txBody>
+          <a:bodyPr/>
+          <a:lstStyle/>
+          <a:p>
+            <a:endParaRPr lang="en-US"/>
+          </a:p>
+        </p:txBody>
       </p:sp>
       <p:sp>
         <p:nvSpPr>
@@ -2993,11 +2694,11 @@
           <a:bodyPr wrap="square" lIns="0" tIns="0" rIns="0" bIns="0" rtlCol="0" anchor="ctr"/>
           <a:lstStyle/>
           <a:p>
-            <a:pPr indent="0" marL="0">
-              <a:buNone/>
-            </a:pPr>
-            <a:r>
-              <a:rPr lang="en-US" sz="1100" b="1" spc="140" kern="0" dirty="0">
+            <a:pPr marL="0" indent="0">
+              <a:buNone/>
+            </a:pPr>
+            <a:r>
+              <a:rPr lang="en-US" sz="1100" b="1" kern="0" spc="140" dirty="0">
                 <a:solidFill>
                   <a:srgbClr val="7048C4"/>
                 </a:solidFill>
@@ -3032,7 +2733,7 @@
           <a:bodyPr wrap="square" lIns="0" tIns="0" rIns="0" bIns="0" rtlCol="0" anchor="ctr"/>
           <a:lstStyle/>
           <a:p>
-            <a:pPr algn="r" indent="0" marL="0">
+            <a:pPr marL="0" indent="0" algn="r">
               <a:buNone/>
             </a:pPr>
             <a:r>
@@ -3071,7 +2772,7 @@
           <a:bodyPr wrap="square" lIns="0" tIns="0" rIns="0" bIns="0" rtlCol="0" anchor="ctr"/>
           <a:lstStyle/>
           <a:p>
-            <a:pPr indent="0" marL="0">
+            <a:pPr marL="0" indent="0">
               <a:buNone/>
             </a:pPr>
             <a:r>
@@ -3110,7 +2811,7 @@
           <a:bodyPr wrap="square" lIns="0" tIns="0" rIns="0" bIns="0" rtlCol="0" anchor="ctr"/>
           <a:lstStyle/>
           <a:p>
-            <a:pPr indent="0" marL="0">
+            <a:pPr marL="0" indent="0">
               <a:buNone/>
             </a:pPr>
             <a:r>
@@ -3149,7 +2850,7 @@
           <a:bodyPr wrap="square" lIns="0" tIns="0" rIns="0" bIns="0" rtlCol="0" anchor="ctr"/>
           <a:lstStyle/>
           <a:p>
-            <a:pPr indent="0" marL="0">
+            <a:pPr marL="0" indent="0">
               <a:buNone/>
             </a:pPr>
             <a:r>
@@ -3183,6 +2884,7 @@
         <a:solidFill>
           <a:srgbClr val="FFFFFF"/>
         </a:solidFill>
+        <a:effectLst/>
       </p:bgPr>
     </p:bg>
     <p:spTree>
@@ -3220,11 +2922,11 @@
           <a:bodyPr wrap="square" lIns="0" tIns="0" rIns="0" bIns="0" rtlCol="0" anchor="ctr"/>
           <a:lstStyle/>
           <a:p>
-            <a:pPr indent="0" marL="0">
-              <a:buNone/>
-            </a:pPr>
-            <a:r>
-              <a:rPr lang="en-US" sz="1200" b="1" spc="160" kern="0" dirty="0">
+            <a:pPr marL="0" indent="0">
+              <a:buNone/>
+            </a:pPr>
+            <a:r>
+              <a:rPr lang="en-US" sz="1200" b="1" kern="0" spc="160" dirty="0">
                 <a:solidFill>
                   <a:srgbClr val="0D9488"/>
                 </a:solidFill>
@@ -3259,7 +2961,7 @@
           <a:bodyPr wrap="square" lIns="0" tIns="0" rIns="0" bIns="0" rtlCol="0" anchor="ctr"/>
           <a:lstStyle/>
           <a:p>
-            <a:pPr indent="0" marL="0">
+            <a:pPr marL="0" indent="0">
               <a:buNone/>
             </a:pPr>
             <a:r>
@@ -3303,6 +3005,13 @@
             <a:prstDash val="solid"/>
           </a:ln>
         </p:spPr>
+        <p:txBody>
+          <a:bodyPr/>
+          <a:lstStyle/>
+          <a:p>
+            <a:endParaRPr lang="en-US"/>
+          </a:p>
+        </p:txBody>
       </p:sp>
       <p:sp>
         <p:nvSpPr>
@@ -3328,6 +3037,13 @@
             <a:prstDash val="solid"/>
           </a:ln>
         </p:spPr>
+        <p:txBody>
+          <a:bodyPr/>
+          <a:lstStyle/>
+          <a:p>
+            <a:endParaRPr lang="en-US"/>
+          </a:p>
+        </p:txBody>
       </p:sp>
       <p:sp>
         <p:nvSpPr>
@@ -3350,11 +3066,11 @@
           <a:bodyPr wrap="square" lIns="0" tIns="0" rIns="0" bIns="0" rtlCol="0" anchor="ctr"/>
           <a:lstStyle/>
           <a:p>
-            <a:pPr indent="0" marL="0">
-              <a:buNone/>
-            </a:pPr>
-            <a:r>
-              <a:rPr lang="en-US" sz="900" b="1" spc="120" kern="0" dirty="0">
+            <a:pPr marL="0" indent="0">
+              <a:buNone/>
+            </a:pPr>
+            <a:r>
+              <a:rPr lang="en-US" sz="900" b="1" kern="0" spc="120" dirty="0">
                 <a:solidFill>
                   <a:srgbClr val="0D9488"/>
                 </a:solidFill>
@@ -3389,7 +3105,7 @@
           <a:bodyPr wrap="square" lIns="0" tIns="0" rIns="0" bIns="0" rtlCol="0" anchor="ctr"/>
           <a:lstStyle/>
           <a:p>
-            <a:pPr indent="0" marL="0">
+            <a:pPr marL="0" indent="0">
               <a:buNone/>
             </a:pPr>
             <a:r>
@@ -3428,7 +3144,7 @@
           <a:bodyPr wrap="square" lIns="0" tIns="0" rIns="0" bIns="0" rtlCol="0" anchor="ctr"/>
           <a:lstStyle/>
           <a:p>
-            <a:pPr indent="0" marL="0">
+            <a:pPr marL="0" indent="0">
               <a:buNone/>
             </a:pPr>
             <a:r>
@@ -3467,7 +3183,7 @@
           <a:bodyPr wrap="square" lIns="0" tIns="0" rIns="0" bIns="0" rtlCol="0" anchor="ctr"/>
           <a:lstStyle/>
           <a:p>
-            <a:pPr indent="0" marL="0">
+            <a:pPr marL="0" indent="0">
               <a:buNone/>
             </a:pPr>
             <a:r>
@@ -3511,6 +3227,13 @@
             <a:prstDash val="solid"/>
           </a:ln>
         </p:spPr>
+        <p:txBody>
+          <a:bodyPr/>
+          <a:lstStyle/>
+          <a:p>
+            <a:endParaRPr lang="en-US"/>
+          </a:p>
+        </p:txBody>
       </p:sp>
       <p:sp>
         <p:nvSpPr>
@@ -3536,6 +3259,13 @@
             <a:prstDash val="solid"/>
           </a:ln>
         </p:spPr>
+        <p:txBody>
+          <a:bodyPr/>
+          <a:lstStyle/>
+          <a:p>
+            <a:endParaRPr lang="en-US"/>
+          </a:p>
+        </p:txBody>
       </p:sp>
       <p:sp>
         <p:nvSpPr>
@@ -3558,11 +3288,11 @@
           <a:bodyPr wrap="square" lIns="0" tIns="0" rIns="0" bIns="0" rtlCol="0" anchor="ctr"/>
           <a:lstStyle/>
           <a:p>
-            <a:pPr indent="0" marL="0">
-              <a:buNone/>
-            </a:pPr>
-            <a:r>
-              <a:rPr lang="en-US" sz="900" b="1" spc="120" kern="0" dirty="0">
+            <a:pPr marL="0" indent="0">
+              <a:buNone/>
+            </a:pPr>
+            <a:r>
+              <a:rPr lang="en-US" sz="900" b="1" kern="0" spc="120" dirty="0">
                 <a:solidFill>
                   <a:srgbClr val="0D9488"/>
                 </a:solidFill>
@@ -3597,7 +3327,7 @@
           <a:bodyPr wrap="square" lIns="0" tIns="0" rIns="0" bIns="0" rtlCol="0" anchor="ctr"/>
           <a:lstStyle/>
           <a:p>
-            <a:pPr indent="0" marL="0">
+            <a:pPr marL="0" indent="0">
               <a:buNone/>
             </a:pPr>
             <a:r>
@@ -3636,7 +3366,7 @@
           <a:bodyPr wrap="square" lIns="0" tIns="0" rIns="0" bIns="0" rtlCol="0" anchor="ctr"/>
           <a:lstStyle/>
           <a:p>
-            <a:pPr indent="0" marL="0">
+            <a:pPr marL="0" indent="0">
               <a:buNone/>
             </a:pPr>
             <a:r>
@@ -3675,7 +3405,7 @@
           <a:bodyPr wrap="square" lIns="0" tIns="0" rIns="0" bIns="0" rtlCol="0" anchor="ctr"/>
           <a:lstStyle/>
           <a:p>
-            <a:pPr indent="0" marL="0">
+            <a:pPr marL="0" indent="0">
               <a:buNone/>
             </a:pPr>
             <a:r>
@@ -3719,6 +3449,13 @@
             <a:prstDash val="solid"/>
           </a:ln>
         </p:spPr>
+        <p:txBody>
+          <a:bodyPr/>
+          <a:lstStyle/>
+          <a:p>
+            <a:endParaRPr lang="en-US"/>
+          </a:p>
+        </p:txBody>
       </p:sp>
       <p:sp>
         <p:nvSpPr>
@@ -3744,6 +3481,13 @@
             <a:prstDash val="solid"/>
           </a:ln>
         </p:spPr>
+        <p:txBody>
+          <a:bodyPr/>
+          <a:lstStyle/>
+          <a:p>
+            <a:endParaRPr lang="en-US"/>
+          </a:p>
+        </p:txBody>
       </p:sp>
       <p:sp>
         <p:nvSpPr>
@@ -3766,11 +3510,11 @@
           <a:bodyPr wrap="square" lIns="0" tIns="0" rIns="0" bIns="0" rtlCol="0" anchor="ctr"/>
           <a:lstStyle/>
           <a:p>
-            <a:pPr indent="0" marL="0">
-              <a:buNone/>
-            </a:pPr>
-            <a:r>
-              <a:rPr lang="en-US" sz="900" b="1" spc="120" kern="0" dirty="0">
+            <a:pPr marL="0" indent="0">
+              <a:buNone/>
+            </a:pPr>
+            <a:r>
+              <a:rPr lang="en-US" sz="900" b="1" kern="0" spc="120" dirty="0">
                 <a:solidFill>
                   <a:srgbClr val="0D9488"/>
                 </a:solidFill>
@@ -3805,7 +3549,7 @@
           <a:bodyPr wrap="square" lIns="0" tIns="0" rIns="0" bIns="0" rtlCol="0" anchor="ctr"/>
           <a:lstStyle/>
           <a:p>
-            <a:pPr indent="0" marL="0">
+            <a:pPr marL="0" indent="0">
               <a:buNone/>
             </a:pPr>
             <a:r>
@@ -3844,7 +3588,7 @@
           <a:bodyPr wrap="square" lIns="0" tIns="0" rIns="0" bIns="0" rtlCol="0" anchor="ctr"/>
           <a:lstStyle/>
           <a:p>
-            <a:pPr indent="0" marL="0">
+            <a:pPr marL="0" indent="0">
               <a:buNone/>
             </a:pPr>
             <a:r>
@@ -3883,7 +3627,7 @@
           <a:bodyPr wrap="square" lIns="0" tIns="0" rIns="0" bIns="0" rtlCol="0" anchor="ctr"/>
           <a:lstStyle/>
           <a:p>
-            <a:pPr indent="0" marL="0">
+            <a:pPr marL="0" indent="0">
               <a:buNone/>
             </a:pPr>
             <a:r>
@@ -3927,6 +3671,13 @@
             <a:prstDash val="solid"/>
           </a:ln>
         </p:spPr>
+        <p:txBody>
+          <a:bodyPr/>
+          <a:lstStyle/>
+          <a:p>
+            <a:endParaRPr lang="en-US"/>
+          </a:p>
+        </p:txBody>
       </p:sp>
       <p:sp>
         <p:nvSpPr>
@@ -3952,6 +3703,13 @@
             <a:prstDash val="solid"/>
           </a:ln>
         </p:spPr>
+        <p:txBody>
+          <a:bodyPr/>
+          <a:lstStyle/>
+          <a:p>
+            <a:endParaRPr lang="en-US"/>
+          </a:p>
+        </p:txBody>
       </p:sp>
       <p:sp>
         <p:nvSpPr>
@@ -3974,11 +3732,11 @@
           <a:bodyPr wrap="square" lIns="0" tIns="0" rIns="0" bIns="0" rtlCol="0" anchor="ctr"/>
           <a:lstStyle/>
           <a:p>
-            <a:pPr indent="0" marL="0">
-              <a:buNone/>
-            </a:pPr>
-            <a:r>
-              <a:rPr lang="en-US" sz="900" b="1" spc="120" kern="0" dirty="0">
+            <a:pPr marL="0" indent="0">
+              <a:buNone/>
+            </a:pPr>
+            <a:r>
+              <a:rPr lang="en-US" sz="900" b="1" kern="0" spc="120" dirty="0">
                 <a:solidFill>
                   <a:srgbClr val="D94F04"/>
                 </a:solidFill>
@@ -4013,7 +3771,7 @@
           <a:bodyPr wrap="square" lIns="0" tIns="0" rIns="0" bIns="0" rtlCol="0" anchor="ctr"/>
           <a:lstStyle/>
           <a:p>
-            <a:pPr indent="0" marL="0">
+            <a:pPr marL="0" indent="0">
               <a:buNone/>
             </a:pPr>
             <a:r>
@@ -4052,7 +3810,7 @@
           <a:bodyPr wrap="square" lIns="0" tIns="0" rIns="0" bIns="0" rtlCol="0" anchor="ctr"/>
           <a:lstStyle/>
           <a:p>
-            <a:pPr indent="0" marL="0">
+            <a:pPr marL="0" indent="0">
               <a:buNone/>
             </a:pPr>
             <a:r>
@@ -4091,7 +3849,7 @@
           <a:bodyPr wrap="square" lIns="0" tIns="0" rIns="0" bIns="0" rtlCol="0" anchor="ctr"/>
           <a:lstStyle/>
           <a:p>
-            <a:pPr indent="0" marL="0">
+            <a:pPr marL="0" indent="0">
               <a:buNone/>
             </a:pPr>
             <a:r>
@@ -4130,7 +3888,7 @@
           <a:bodyPr wrap="square" lIns="0" tIns="0" rIns="0" bIns="0" rtlCol="0" anchor="ctr"/>
           <a:lstStyle/>
           <a:p>
-            <a:pPr indent="0" marL="0">
+            <a:pPr marL="0" indent="0">
               <a:buNone/>
             </a:pPr>
             <a:r>
@@ -4144,9 +3902,6 @@
               </a:rPr>
               <a:t>The fourth dataset was meant to be the dependent variable. </a:t>
             </a:r>
-            <a:pPr indent="0" marL="0">
-              <a:buNone/>
-            </a:pPr>
             <a:r>
               <a:rPr lang="en-US" sz="1300" dirty="0">
                 <a:solidFill>
@@ -4178,6 +3933,7 @@
         <a:solidFill>
           <a:srgbClr val="FFFFFF"/>
         </a:solidFill>
+        <a:effectLst/>
       </p:bgPr>
     </p:bg>
     <p:spTree>
@@ -4215,11 +3971,11 @@
           <a:bodyPr wrap="square" lIns="0" tIns="0" rIns="0" bIns="0" rtlCol="0" anchor="ctr"/>
           <a:lstStyle/>
           <a:p>
-            <a:pPr indent="0" marL="0">
-              <a:buNone/>
-            </a:pPr>
-            <a:r>
-              <a:rPr lang="en-US" sz="1200" b="1" spc="160" kern="0" dirty="0">
+            <a:pPr marL="0" indent="0">
+              <a:buNone/>
+            </a:pPr>
+            <a:r>
+              <a:rPr lang="en-US" sz="1200" b="1" kern="0" spc="160" dirty="0">
                 <a:solidFill>
                   <a:srgbClr val="0D9488"/>
                 </a:solidFill>
@@ -4254,7 +4010,7 @@
           <a:bodyPr wrap="square" lIns="0" tIns="0" rIns="0" bIns="0" rtlCol="0" anchor="ctr"/>
           <a:lstStyle/>
           <a:p>
-            <a:pPr indent="0" marL="0">
+            <a:pPr marL="0" indent="0">
               <a:buNone/>
             </a:pPr>
             <a:r>
@@ -4274,7 +4030,7 @@
       </p:sp>
       <p:graphicFrame>
         <p:nvGraphicFramePr>
-          <p:cNvPr id="4" name="Chart 0" descr=""/>
+          <p:cNvPr id="4" name="Chart 0"/>
           <p:cNvGraphicFramePr/>
           <p:nvPr/>
         </p:nvGraphicFramePr>
@@ -4282,9 +4038,9 @@
           <a:off x="640080" y="1645920"/>
           <a:ext cx="5623560" cy="2926080"/>
         </p:xfrm>
-        <a:graphic xmlns:a="http://schemas.openxmlformats.org/drawingml/2006/main">
+        <a:graphic>
           <a:graphicData uri="http://schemas.openxmlformats.org/drawingml/2006/chart">
-            <c:chart xmlns:c="http://schemas.openxmlformats.org/drawingml/2006/chart" r:id="rId1"/>
+            <c:chart xmlns:c="http://schemas.openxmlformats.org/drawingml/2006/chart" xmlns:r="http://schemas.openxmlformats.org/officeDocument/2006/relationships" r:id="rId3"/>
           </a:graphicData>
         </a:graphic>
       </p:graphicFrame>
@@ -4309,7 +4065,7 @@
           <a:bodyPr wrap="square" lIns="0" tIns="0" rIns="0" bIns="0" rtlCol="0" anchor="ctr"/>
           <a:lstStyle/>
           <a:p>
-            <a:pPr indent="0" marL="0">
+            <a:pPr marL="0" indent="0">
               <a:buNone/>
             </a:pPr>
             <a:r>
@@ -4353,6 +4109,13 @@
             <a:prstDash val="solid"/>
           </a:ln>
         </p:spPr>
+        <p:txBody>
+          <a:bodyPr/>
+          <a:lstStyle/>
+          <a:p>
+            <a:endParaRPr lang="en-US"/>
+          </a:p>
+        </p:txBody>
       </p:sp>
       <p:sp>
         <p:nvSpPr>
@@ -4375,7 +4138,7 @@
           <a:bodyPr wrap="square" lIns="0" tIns="0" rIns="0" bIns="0" rtlCol="0" anchor="ctr"/>
           <a:lstStyle/>
           <a:p>
-            <a:pPr algn="ctr" indent="0" marL="0">
+            <a:pPr marL="0" indent="0" algn="ctr">
               <a:buNone/>
             </a:pPr>
             <a:r>
@@ -4414,7 +4177,7 @@
           <a:bodyPr wrap="square" lIns="0" tIns="0" rIns="0" bIns="0" rtlCol="0" anchor="ctr"/>
           <a:lstStyle/>
           <a:p>
-            <a:pPr algn="ctr" indent="0" marL="0">
+            <a:pPr marL="0" indent="0" algn="ctr">
               <a:buNone/>
             </a:pPr>
             <a:r>
@@ -4431,7 +4194,7 @@
             <a:endParaRPr lang="en-US" sz="1050" dirty="0"/>
           </a:p>
           <a:p>
-            <a:pPr algn="ctr" indent="0" marL="0">
+            <a:pPr marL="0" indent="0" algn="ctr">
               <a:buNone/>
             </a:pPr>
             <a:r>
@@ -4475,6 +4238,13 @@
             <a:prstDash val="solid"/>
           </a:ln>
         </p:spPr>
+        <p:txBody>
+          <a:bodyPr/>
+          <a:lstStyle/>
+          <a:p>
+            <a:endParaRPr lang="en-US"/>
+          </a:p>
+        </p:txBody>
       </p:sp>
       <p:sp>
         <p:nvSpPr>
@@ -4497,7 +4267,7 @@
           <a:bodyPr wrap="square" lIns="0" tIns="0" rIns="0" bIns="0" rtlCol="0" anchor="ctr"/>
           <a:lstStyle/>
           <a:p>
-            <a:pPr algn="ctr" indent="0" marL="0">
+            <a:pPr marL="0" indent="0" algn="ctr">
               <a:buNone/>
             </a:pPr>
             <a:r>
@@ -4536,7 +4306,7 @@
           <a:bodyPr wrap="square" lIns="0" tIns="0" rIns="0" bIns="0" rtlCol="0" anchor="ctr"/>
           <a:lstStyle/>
           <a:p>
-            <a:pPr algn="ctr" indent="0" marL="0">
+            <a:pPr marL="0" indent="0" algn="ctr">
               <a:buNone/>
             </a:pPr>
             <a:r>
@@ -4553,7 +4323,7 @@
             <a:endParaRPr lang="en-US" sz="1050" dirty="0"/>
           </a:p>
           <a:p>
-            <a:pPr algn="ctr" indent="0" marL="0">
+            <a:pPr marL="0" indent="0" algn="ctr">
               <a:buNone/>
             </a:pPr>
             <a:r>
@@ -4597,6 +4367,13 @@
             <a:prstDash val="solid"/>
           </a:ln>
         </p:spPr>
+        <p:txBody>
+          <a:bodyPr/>
+          <a:lstStyle/>
+          <a:p>
+            <a:endParaRPr lang="en-US"/>
+          </a:p>
+        </p:txBody>
       </p:sp>
       <p:sp>
         <p:nvSpPr>
@@ -4619,7 +4396,7 @@
           <a:bodyPr wrap="square" lIns="0" tIns="0" rIns="0" bIns="0" rtlCol="0" anchor="ctr"/>
           <a:lstStyle/>
           <a:p>
-            <a:pPr algn="ctr" indent="0" marL="0">
+            <a:pPr marL="0" indent="0" algn="ctr">
               <a:buNone/>
             </a:pPr>
             <a:r>
@@ -4658,7 +4435,7 @@
           <a:bodyPr wrap="square" lIns="0" tIns="0" rIns="0" bIns="0" rtlCol="0" anchor="ctr"/>
           <a:lstStyle/>
           <a:p>
-            <a:pPr algn="ctr" indent="0" marL="0">
+            <a:pPr marL="0" indent="0" algn="ctr">
               <a:buNone/>
             </a:pPr>
             <a:r>
@@ -4675,7 +4452,7 @@
             <a:endParaRPr lang="en-US" sz="1050" dirty="0"/>
           </a:p>
           <a:p>
-            <a:pPr algn="ctr" indent="0" marL="0">
+            <a:pPr marL="0" indent="0" algn="ctr">
               <a:buNone/>
             </a:pPr>
             <a:r>
@@ -4719,6 +4496,13 @@
             <a:prstDash val="solid"/>
           </a:ln>
         </p:spPr>
+        <p:txBody>
+          <a:bodyPr/>
+          <a:lstStyle/>
+          <a:p>
+            <a:endParaRPr lang="en-US"/>
+          </a:p>
+        </p:txBody>
       </p:sp>
       <p:sp>
         <p:nvSpPr>
@@ -4741,7 +4525,7 @@
           <a:bodyPr wrap="square" lIns="0" tIns="0" rIns="0" bIns="0" rtlCol="0" anchor="ctr"/>
           <a:lstStyle/>
           <a:p>
-            <a:pPr algn="ctr" indent="0" marL="0">
+            <a:pPr marL="0" indent="0" algn="ctr">
               <a:buNone/>
             </a:pPr>
             <a:r>
@@ -4780,7 +4564,7 @@
           <a:bodyPr wrap="square" lIns="0" tIns="0" rIns="0" bIns="0" rtlCol="0" anchor="ctr"/>
           <a:lstStyle/>
           <a:p>
-            <a:pPr algn="ctr" indent="0" marL="0">
+            <a:pPr marL="0" indent="0" algn="ctr">
               <a:buNone/>
             </a:pPr>
             <a:r>
@@ -4797,7 +4581,7 @@
             <a:endParaRPr lang="en-US" sz="1050" dirty="0"/>
           </a:p>
           <a:p>
-            <a:pPr algn="ctr" indent="0" marL="0">
+            <a:pPr marL="0" indent="0" algn="ctr">
               <a:buNone/>
             </a:pPr>
             <a:r>
@@ -4836,7 +4620,7 @@
           <a:bodyPr wrap="square" lIns="0" tIns="0" rIns="0" bIns="0" rtlCol="0" anchor="ctr"/>
           <a:lstStyle/>
           <a:p>
-            <a:pPr indent="0" marL="0">
+            <a:pPr marL="0" indent="0">
               <a:buNone/>
             </a:pPr>
             <a:r>
@@ -4850,9 +4634,6 @@
               </a:rPr>
               <a:t>Why this matters:  </a:t>
             </a:r>
-            <a:pPr indent="0" marL="0">
-              <a:buNone/>
-            </a:pPr>
             <a:r>
               <a:rPr lang="en-US" sz="1300" dirty="0">
                 <a:solidFill>
@@ -4889,7 +4670,7 @@
           <a:bodyPr wrap="square" lIns="0" tIns="0" rIns="0" bIns="0" rtlCol="0" anchor="ctr"/>
           <a:lstStyle/>
           <a:p>
-            <a:pPr indent="0" marL="0">
+            <a:pPr marL="0" indent="0">
               <a:buNone/>
             </a:pPr>
             <a:r>
@@ -4903,9 +4684,6 @@
               </a:rPr>
               <a:t>First lead test gives +0.24 at k=0, −0.20 at k=1, +0.40 at k=2. </a:t>
             </a:r>
-            <a:pPr indent="0" marL="0">
-              <a:buNone/>
-            </a:pPr>
             <a:r>
               <a:rPr lang="en-US" sz="1300" dirty="0">
                 <a:solidFill>
@@ -4937,6 +4715,7 @@
         <a:solidFill>
           <a:srgbClr val="FFFFFF"/>
         </a:solidFill>
+        <a:effectLst/>
       </p:bgPr>
     </p:bg>
     <p:spTree>
@@ -4974,11 +4753,11 @@
           <a:bodyPr wrap="square" lIns="0" tIns="0" rIns="0" bIns="0" rtlCol="0" anchor="ctr"/>
           <a:lstStyle/>
           <a:p>
-            <a:pPr indent="0" marL="0">
-              <a:buNone/>
-            </a:pPr>
-            <a:r>
-              <a:rPr lang="en-US" sz="1200" b="1" spc="160" kern="0" dirty="0">
+            <a:pPr marL="0" indent="0">
+              <a:buNone/>
+            </a:pPr>
+            <a:r>
+              <a:rPr lang="en-US" sz="1200" b="1" kern="0" spc="160" dirty="0">
                 <a:solidFill>
                   <a:srgbClr val="0D9488"/>
                 </a:solidFill>
@@ -5013,7 +4792,7 @@
           <a:bodyPr wrap="square" lIns="0" tIns="0" rIns="0" bIns="0" rtlCol="0" anchor="ctr"/>
           <a:lstStyle/>
           <a:p>
-            <a:pPr indent="0" marL="0">
+            <a:pPr marL="0" indent="0">
               <a:buNone/>
             </a:pPr>
             <a:r>
@@ -5057,6 +4836,13 @@
             <a:prstDash val="solid"/>
           </a:ln>
         </p:spPr>
+        <p:txBody>
+          <a:bodyPr/>
+          <a:lstStyle/>
+          <a:p>
+            <a:endParaRPr lang="en-US"/>
+          </a:p>
+        </p:txBody>
       </p:sp>
       <p:sp>
         <p:nvSpPr>
@@ -5082,6 +4868,13 @@
             <a:prstDash val="solid"/>
           </a:ln>
         </p:spPr>
+        <p:txBody>
+          <a:bodyPr/>
+          <a:lstStyle/>
+          <a:p>
+            <a:endParaRPr lang="en-US"/>
+          </a:p>
+        </p:txBody>
       </p:sp>
       <p:sp>
         <p:nvSpPr>
@@ -5104,7 +4897,7 @@
           <a:bodyPr wrap="square" lIns="0" tIns="0" rIns="0" bIns="0" rtlCol="0" anchor="ctr"/>
           <a:lstStyle/>
           <a:p>
-            <a:pPr indent="0" marL="0">
+            <a:pPr marL="0" indent="0">
               <a:buNone/>
             </a:pPr>
             <a:r>
@@ -5230,7 +5023,7 @@
       </p:sp>
       <p:graphicFrame>
         <p:nvGraphicFramePr>
-          <p:cNvPr id="8" name="Chart 0" descr=""/>
+          <p:cNvPr id="8" name="Chart 0"/>
           <p:cNvGraphicFramePr/>
           <p:nvPr/>
         </p:nvGraphicFramePr>
@@ -5238,9 +5031,9 @@
           <a:off x="4709160" y="1645920"/>
           <a:ext cx="6830568" cy="2880360"/>
         </p:xfrm>
-        <a:graphic xmlns:a="http://schemas.openxmlformats.org/drawingml/2006/main">
+        <a:graphic>
           <a:graphicData uri="http://schemas.openxmlformats.org/drawingml/2006/chart">
-            <c:chart xmlns:c="http://schemas.openxmlformats.org/drawingml/2006/chart" r:id="rId1"/>
+            <c:chart xmlns:c="http://schemas.openxmlformats.org/drawingml/2006/chart" xmlns:r="http://schemas.openxmlformats.org/officeDocument/2006/relationships" r:id="rId3"/>
           </a:graphicData>
         </a:graphic>
       </p:graphicFrame>
@@ -5265,7 +5058,7 @@
           <a:bodyPr wrap="square" lIns="0" tIns="0" rIns="0" bIns="0" rtlCol="0" anchor="ctr"/>
           <a:lstStyle/>
           <a:p>
-            <a:pPr indent="0" marL="0">
+            <a:pPr marL="0" indent="0">
               <a:buNone/>
             </a:pPr>
             <a:r>
@@ -5309,6 +5102,13 @@
             <a:prstDash val="solid"/>
           </a:ln>
         </p:spPr>
+        <p:txBody>
+          <a:bodyPr/>
+          <a:lstStyle/>
+          <a:p>
+            <a:endParaRPr lang="en-US"/>
+          </a:p>
+        </p:txBody>
       </p:sp>
       <p:sp>
         <p:nvSpPr>
@@ -5331,7 +5131,7 @@
           <a:bodyPr wrap="square" lIns="0" tIns="0" rIns="0" bIns="0" rtlCol="0" anchor="ctr"/>
           <a:lstStyle/>
           <a:p>
-            <a:pPr algn="ctr" indent="0" marL="0">
+            <a:pPr marL="0" indent="0" algn="ctr">
               <a:buNone/>
             </a:pPr>
             <a:r>
@@ -5370,7 +5170,7 @@
           <a:bodyPr wrap="square" lIns="0" tIns="0" rIns="0" bIns="0" rtlCol="0" anchor="ctr"/>
           <a:lstStyle/>
           <a:p>
-            <a:pPr algn="ctr" indent="0" marL="0">
+            <a:pPr marL="0" indent="0" algn="ctr">
               <a:buNone/>
             </a:pPr>
             <a:r>
@@ -5414,6 +5214,13 @@
             <a:prstDash val="solid"/>
           </a:ln>
         </p:spPr>
+        <p:txBody>
+          <a:bodyPr/>
+          <a:lstStyle/>
+          <a:p>
+            <a:endParaRPr lang="en-US"/>
+          </a:p>
+        </p:txBody>
       </p:sp>
       <p:sp>
         <p:nvSpPr>
@@ -5436,7 +5243,7 @@
           <a:bodyPr wrap="square" lIns="0" tIns="0" rIns="0" bIns="0" rtlCol="0" anchor="ctr"/>
           <a:lstStyle/>
           <a:p>
-            <a:pPr algn="ctr" indent="0" marL="0">
+            <a:pPr marL="0" indent="0" algn="ctr">
               <a:buNone/>
             </a:pPr>
             <a:r>
@@ -5475,7 +5282,7 @@
           <a:bodyPr wrap="square" lIns="0" tIns="0" rIns="0" bIns="0" rtlCol="0" anchor="ctr"/>
           <a:lstStyle/>
           <a:p>
-            <a:pPr algn="ctr" indent="0" marL="0">
+            <a:pPr marL="0" indent="0" algn="ctr">
               <a:buNone/>
             </a:pPr>
             <a:r>
@@ -5514,7 +5321,7 @@
           <a:bodyPr wrap="square" lIns="0" tIns="0" rIns="0" bIns="0" rtlCol="0" anchor="ctr"/>
           <a:lstStyle/>
           <a:p>
-            <a:pPr indent="0" marL="0">
+            <a:pPr marL="0" indent="0">
               <a:buNone/>
             </a:pPr>
             <a:r>
@@ -5528,9 +5335,6 @@
               </a:rPr>
               <a:t>At our 16 events a moderate effect is caught 15% of the time. </a:t>
             </a:r>
-            <a:pPr indent="0" marL="0">
-              <a:buNone/>
-            </a:pPr>
             <a:r>
               <a:rPr lang="en-US" sz="1300" dirty="0">
                 <a:solidFill>
@@ -5562,6 +5366,7 @@
         <a:solidFill>
           <a:srgbClr val="FFFFFF"/>
         </a:solidFill>
+        <a:effectLst/>
       </p:bgPr>
     </p:bg>
     <p:spTree>
@@ -5599,11 +5404,11 @@
           <a:bodyPr wrap="square" lIns="0" tIns="0" rIns="0" bIns="0" rtlCol="0" anchor="ctr"/>
           <a:lstStyle/>
           <a:p>
-            <a:pPr indent="0" marL="0">
-              <a:buNone/>
-            </a:pPr>
-            <a:r>
-              <a:rPr lang="en-US" sz="1200" b="1" spc="160" kern="0" dirty="0">
+            <a:pPr marL="0" indent="0">
+              <a:buNone/>
+            </a:pPr>
+            <a:r>
+              <a:rPr lang="en-US" sz="1200" b="1" kern="0" spc="160" dirty="0">
                 <a:solidFill>
                   <a:srgbClr val="0D9488"/>
                 </a:solidFill>
@@ -5638,7 +5443,7 @@
           <a:bodyPr wrap="square" lIns="0" tIns="0" rIns="0" bIns="0" rtlCol="0" anchor="ctr"/>
           <a:lstStyle/>
           <a:p>
-            <a:pPr indent="0" marL="0">
+            <a:pPr marL="0" indent="0">
               <a:buNone/>
             </a:pPr>
             <a:r>
@@ -5680,6 +5485,13 @@
             <a:prstDash val="solid"/>
           </a:ln>
         </p:spPr>
+        <p:txBody>
+          <a:bodyPr/>
+          <a:lstStyle/>
+          <a:p>
+            <a:endParaRPr lang="en-US"/>
+          </a:p>
+        </p:txBody>
       </p:sp>
       <p:sp>
         <p:nvSpPr>
@@ -5702,7 +5514,7 @@
           <a:bodyPr wrap="square" lIns="0" tIns="0" rIns="0" bIns="0" rtlCol="0" anchor="ctr"/>
           <a:lstStyle/>
           <a:p>
-            <a:pPr algn="ctr" indent="0" marL="0">
+            <a:pPr marL="0" indent="0" algn="ctr">
               <a:buNone/>
             </a:pPr>
             <a:r>
@@ -5741,7 +5553,7 @@
           <a:bodyPr wrap="square" lIns="0" tIns="0" rIns="0" bIns="0" rtlCol="0" anchor="ctr"/>
           <a:lstStyle/>
           <a:p>
-            <a:pPr indent="0" marL="0">
+            <a:pPr marL="0" indent="0">
               <a:buNone/>
             </a:pPr>
             <a:r>
@@ -5780,7 +5592,7 @@
           <a:bodyPr wrap="square" lIns="0" tIns="0" rIns="0" bIns="0" rtlCol="0" anchor="ctr"/>
           <a:lstStyle/>
           <a:p>
-            <a:pPr indent="0" marL="0">
+            <a:pPr marL="0" indent="0">
               <a:buNone/>
             </a:pPr>
             <a:r>
@@ -5822,6 +5634,13 @@
             <a:prstDash val="solid"/>
           </a:ln>
         </p:spPr>
+        <p:txBody>
+          <a:bodyPr/>
+          <a:lstStyle/>
+          <a:p>
+            <a:endParaRPr lang="en-US"/>
+          </a:p>
+        </p:txBody>
       </p:sp>
       <p:sp>
         <p:nvSpPr>
@@ -5844,7 +5663,7 @@
           <a:bodyPr wrap="square" lIns="0" tIns="0" rIns="0" bIns="0" rtlCol="0" anchor="ctr"/>
           <a:lstStyle/>
           <a:p>
-            <a:pPr algn="ctr" indent="0" marL="0">
+            <a:pPr marL="0" indent="0" algn="ctr">
               <a:buNone/>
             </a:pPr>
             <a:r>
@@ -5883,7 +5702,7 @@
           <a:bodyPr wrap="square" lIns="0" tIns="0" rIns="0" bIns="0" rtlCol="0" anchor="ctr"/>
           <a:lstStyle/>
           <a:p>
-            <a:pPr indent="0" marL="0">
+            <a:pPr marL="0" indent="0">
               <a:buNone/>
             </a:pPr>
             <a:r>
@@ -5922,7 +5741,7 @@
           <a:bodyPr wrap="square" lIns="0" tIns="0" rIns="0" bIns="0" rtlCol="0" anchor="ctr"/>
           <a:lstStyle/>
           <a:p>
-            <a:pPr indent="0" marL="0">
+            <a:pPr marL="0" indent="0">
               <a:buNone/>
             </a:pPr>
             <a:r>
@@ -5964,6 +5783,13 @@
             <a:prstDash val="solid"/>
           </a:ln>
         </p:spPr>
+        <p:txBody>
+          <a:bodyPr/>
+          <a:lstStyle/>
+          <a:p>
+            <a:endParaRPr lang="en-US"/>
+          </a:p>
+        </p:txBody>
       </p:sp>
       <p:sp>
         <p:nvSpPr>
@@ -5986,7 +5812,7 @@
           <a:bodyPr wrap="square" lIns="0" tIns="0" rIns="0" bIns="0" rtlCol="0" anchor="ctr"/>
           <a:lstStyle/>
           <a:p>
-            <a:pPr algn="ctr" indent="0" marL="0">
+            <a:pPr marL="0" indent="0" algn="ctr">
               <a:buNone/>
             </a:pPr>
             <a:r>
@@ -6025,7 +5851,7 @@
           <a:bodyPr wrap="square" lIns="0" tIns="0" rIns="0" bIns="0" rtlCol="0" anchor="ctr"/>
           <a:lstStyle/>
           <a:p>
-            <a:pPr indent="0" marL="0">
+            <a:pPr marL="0" indent="0">
               <a:buNone/>
             </a:pPr>
             <a:r>
@@ -6064,7 +5890,7 @@
           <a:bodyPr wrap="square" lIns="0" tIns="0" rIns="0" bIns="0" rtlCol="0" anchor="ctr"/>
           <a:lstStyle/>
           <a:p>
-            <a:pPr indent="0" marL="0">
+            <a:pPr marL="0" indent="0">
               <a:buNone/>
             </a:pPr>
             <a:r>
@@ -6106,6 +5932,13 @@
             <a:prstDash val="solid"/>
           </a:ln>
         </p:spPr>
+        <p:txBody>
+          <a:bodyPr/>
+          <a:lstStyle/>
+          <a:p>
+            <a:endParaRPr lang="en-US"/>
+          </a:p>
+        </p:txBody>
       </p:sp>
       <p:sp>
         <p:nvSpPr>
@@ -6128,7 +5961,7 @@
           <a:bodyPr wrap="square" lIns="0" tIns="0" rIns="0" bIns="0" rtlCol="0" anchor="ctr"/>
           <a:lstStyle/>
           <a:p>
-            <a:pPr algn="ctr" indent="0" marL="0">
+            <a:pPr marL="0" indent="0" algn="ctr">
               <a:buNone/>
             </a:pPr>
             <a:r>
@@ -6167,7 +6000,7 @@
           <a:bodyPr wrap="square" lIns="0" tIns="0" rIns="0" bIns="0" rtlCol="0" anchor="ctr"/>
           <a:lstStyle/>
           <a:p>
-            <a:pPr indent="0" marL="0">
+            <a:pPr marL="0" indent="0">
               <a:buNone/>
             </a:pPr>
             <a:r>
@@ -6206,7 +6039,7 @@
           <a:bodyPr wrap="square" lIns="0" tIns="0" rIns="0" bIns="0" rtlCol="0" anchor="ctr"/>
           <a:lstStyle/>
           <a:p>
-            <a:pPr indent="0" marL="0">
+            <a:pPr marL="0" indent="0">
               <a:buNone/>
             </a:pPr>
             <a:r>
@@ -6248,6 +6081,13 @@
             <a:prstDash val="solid"/>
           </a:ln>
         </p:spPr>
+        <p:txBody>
+          <a:bodyPr/>
+          <a:lstStyle/>
+          <a:p>
+            <a:endParaRPr lang="en-US"/>
+          </a:p>
+        </p:txBody>
       </p:sp>
       <p:sp>
         <p:nvSpPr>
@@ -6270,7 +6110,7 @@
           <a:bodyPr wrap="square" lIns="0" tIns="0" rIns="0" bIns="0" rtlCol="0" anchor="ctr"/>
           <a:lstStyle/>
           <a:p>
-            <a:pPr algn="ctr" indent="0" marL="0">
+            <a:pPr marL="0" indent="0" algn="ctr">
               <a:buNone/>
             </a:pPr>
             <a:r>
@@ -6309,7 +6149,7 @@
           <a:bodyPr wrap="square" lIns="0" tIns="0" rIns="0" bIns="0" rtlCol="0" anchor="ctr"/>
           <a:lstStyle/>
           <a:p>
-            <a:pPr indent="0" marL="0">
+            <a:pPr marL="0" indent="0">
               <a:buNone/>
             </a:pPr>
             <a:r>
@@ -6348,7 +6188,7 @@
           <a:bodyPr wrap="square" lIns="0" tIns="0" rIns="0" bIns="0" rtlCol="0" anchor="ctr"/>
           <a:lstStyle/>
           <a:p>
-            <a:pPr indent="0" marL="0">
+            <a:pPr marL="0" indent="0">
               <a:buNone/>
             </a:pPr>
             <a:r>
@@ -6363,6 +6203,48 @@
               <a:t>Including the negative result on the investment source, which is a finding about alt-data coverage in its own right.</a:t>
             </a:r>
             <a:endParaRPr lang="en-US" sz="1250" dirty="0"/>
+          </a:p>
+        </p:txBody>
+      </p:sp>
+      <p:sp>
+        <p:nvSpPr>
+          <p:cNvPr id="24" name="Text 16">
+            <a:extLst>
+              <a:ext uri="{FF2B5EF4-FFF2-40B4-BE49-F238E27FC236}">
+                <a16:creationId xmlns:a16="http://schemas.microsoft.com/office/drawing/2014/main" id="{8D6DF415-B2F2-7FF5-B6B7-A65FAFE9E3FE}"/>
+              </a:ext>
+            </a:extLst>
+          </p:cNvPr>
+          <p:cNvSpPr txBox="1"/>
+          <p:nvPr/>
+        </p:nvSpPr>
+        <p:spPr>
+          <a:xfrm>
+            <a:off x="7799832" y="6062472"/>
+            <a:ext cx="3721608" cy="420624"/>
+          </a:xfrm>
+          <a:prstGeom prst="rect">
+            <a:avLst/>
+          </a:prstGeom>
+          <a:noFill/>
+          <a:ln/>
+        </p:spPr>
+        <p:txBody>
+          <a:bodyPr wrap="square" lIns="0" tIns="0" rIns="0" bIns="0" rtlCol="0" anchor="ctr"/>
+          <a:lstStyle/>
+          <a:p>
+            <a:pPr marL="0" indent="0" algn="r">
+              <a:buNone/>
+            </a:pPr>
+            <a:r>
+              <a:rPr lang="en-US" sz="950" dirty="0">
+                <a:latin typeface="Calibri" pitchFamily="34" charset="0"/>
+                <a:ea typeface="Calibri" pitchFamily="34" charset="-122"/>
+                <a:cs typeface="Calibri" pitchFamily="34" charset="-120"/>
+              </a:rPr>
+              <a:t>Slide design and layout generated with Claude (Anthropic Claude Code)</a:t>
+            </a:r>
+            <a:endParaRPr lang="en-US" sz="950" dirty="0"/>
           </a:p>
         </p:txBody>
       </p:sp>
@@ -6382,6 +6264,7 @@
         <a:solidFill>
           <a:srgbClr val="0B3B38"/>
         </a:solidFill>
+        <a:effectLst/>
       </p:bgPr>
     </p:bg>
     <p:spTree>
@@ -6422,6 +6305,13 @@
             <a:prstDash val="solid"/>
           </a:ln>
         </p:spPr>
+        <p:txBody>
+          <a:bodyPr/>
+          <a:lstStyle/>
+          <a:p>
+            <a:endParaRPr lang="en-US"/>
+          </a:p>
+        </p:txBody>
       </p:sp>
       <p:sp>
         <p:nvSpPr>
@@ -6444,11 +6334,11 @@
           <a:bodyPr wrap="square" lIns="0" tIns="0" rIns="0" bIns="0" rtlCol="0" anchor="ctr"/>
           <a:lstStyle/>
           <a:p>
-            <a:pPr indent="0" marL="0">
-              <a:buNone/>
-            </a:pPr>
-            <a:r>
-              <a:rPr lang="en-US" sz="1200" b="1" spc="160" kern="0" dirty="0">
+            <a:pPr marL="0" indent="0">
+              <a:buNone/>
+            </a:pPr>
+            <a:r>
+              <a:rPr lang="en-US" sz="1200" b="1" kern="0" spc="160" dirty="0">
                 <a:solidFill>
                   <a:srgbClr val="F0A98A"/>
                 </a:solidFill>
@@ -6483,7 +6373,7 @@
           <a:bodyPr wrap="square" lIns="0" tIns="0" rIns="0" bIns="0" rtlCol="0" anchor="ctr"/>
           <a:lstStyle/>
           <a:p>
-            <a:pPr indent="0" marL="0">
+            <a:pPr marL="0" indent="0">
               <a:buNone/>
             </a:pPr>
             <a:r>
@@ -6527,6 +6417,13 @@
             <a:prstDash val="solid"/>
           </a:ln>
         </p:spPr>
+        <p:txBody>
+          <a:bodyPr/>
+          <a:lstStyle/>
+          <a:p>
+            <a:endParaRPr lang="en-US"/>
+          </a:p>
+        </p:txBody>
       </p:sp>
       <p:sp>
         <p:nvSpPr>
@@ -6549,7 +6446,7 @@
           <a:bodyPr wrap="square" lIns="0" tIns="0" rIns="0" bIns="0" rtlCol="0" anchor="ctr"/>
           <a:lstStyle/>
           <a:p>
-            <a:pPr indent="0" marL="0">
+            <a:pPr marL="0" indent="0">
               <a:buNone/>
             </a:pPr>
             <a:r>
@@ -6588,7 +6485,7 @@
           <a:bodyPr wrap="square" lIns="0" tIns="0" rIns="0" bIns="0" rtlCol="0" anchor="ctr"/>
           <a:lstStyle/>
           <a:p>
-            <a:pPr indent="0" marL="0">
+            <a:pPr marL="0" indent="0">
               <a:buNone/>
             </a:pPr>
             <a:r>
@@ -6632,6 +6529,13 @@
             <a:prstDash val="solid"/>
           </a:ln>
         </p:spPr>
+        <p:txBody>
+          <a:bodyPr/>
+          <a:lstStyle/>
+          <a:p>
+            <a:endParaRPr lang="en-US"/>
+          </a:p>
+        </p:txBody>
       </p:sp>
       <p:sp>
         <p:nvSpPr>
@@ -6654,7 +6558,7 @@
           <a:bodyPr wrap="square" lIns="0" tIns="0" rIns="0" bIns="0" rtlCol="0" anchor="ctr"/>
           <a:lstStyle/>
           <a:p>
-            <a:pPr indent="0" marL="0">
+            <a:pPr marL="0" indent="0">
               <a:buNone/>
             </a:pPr>
             <a:r>
@@ -6693,7 +6597,7 @@
           <a:bodyPr wrap="square" lIns="0" tIns="0" rIns="0" bIns="0" rtlCol="0" anchor="ctr"/>
           <a:lstStyle/>
           <a:p>
-            <a:pPr indent="0" marL="0">
+            <a:pPr marL="0" indent="0">
               <a:buNone/>
             </a:pPr>
             <a:r>
@@ -6737,6 +6641,13 @@
             <a:prstDash val="solid"/>
           </a:ln>
         </p:spPr>
+        <p:txBody>
+          <a:bodyPr/>
+          <a:lstStyle/>
+          <a:p>
+            <a:endParaRPr lang="en-US"/>
+          </a:p>
+        </p:txBody>
       </p:sp>
       <p:sp>
         <p:nvSpPr>
@@ -6759,7 +6670,7 @@
           <a:bodyPr wrap="square" lIns="0" tIns="0" rIns="0" bIns="0" rtlCol="0" anchor="ctr"/>
           <a:lstStyle/>
           <a:p>
-            <a:pPr indent="0" marL="0">
+            <a:pPr marL="0" indent="0">
               <a:buNone/>
             </a:pPr>
             <a:r>
@@ -6798,7 +6709,7 @@
           <a:bodyPr wrap="square" lIns="0" tIns="0" rIns="0" bIns="0" rtlCol="0" anchor="ctr"/>
           <a:lstStyle/>
           <a:p>
-            <a:pPr indent="0" marL="0">
+            <a:pPr marL="0" indent="0">
               <a:buNone/>
             </a:pPr>
             <a:r>
@@ -6842,6 +6753,13 @@
             <a:prstDash val="solid"/>
           </a:ln>
         </p:spPr>
+        <p:txBody>
+          <a:bodyPr/>
+          <a:lstStyle/>
+          <a:p>
+            <a:endParaRPr lang="en-US"/>
+          </a:p>
+        </p:txBody>
       </p:sp>
       <p:sp>
         <p:nvSpPr>
@@ -6864,11 +6782,11 @@
           <a:bodyPr wrap="square" lIns="0" tIns="0" rIns="0" bIns="0" rtlCol="0" anchor="ctr"/>
           <a:lstStyle/>
           <a:p>
-            <a:pPr indent="0" marL="0">
-              <a:buNone/>
-            </a:pPr>
-            <a:r>
-              <a:rPr lang="en-US" sz="1050" b="1" spc="120" kern="0" dirty="0">
+            <a:pPr marL="0" indent="0">
+              <a:buNone/>
+            </a:pPr>
+            <a:r>
+              <a:rPr lang="en-US" sz="1050" b="1" kern="0" spc="120" dirty="0">
                 <a:solidFill>
                   <a:srgbClr val="D94F04"/>
                 </a:solidFill>
@@ -7009,7 +6927,7 @@
           <a:bodyPr wrap="square" lIns="0" tIns="0" rIns="0" bIns="0" rtlCol="0" anchor="ctr"/>
           <a:lstStyle/>
           <a:p>
-            <a:pPr indent="0" marL="0">
+            <a:pPr marL="0" indent="0">
               <a:buNone/>
             </a:pPr>
             <a:r>
@@ -7035,20 +6953,20 @@
         </p:nvSpPr>
         <p:spPr>
           <a:xfrm>
-            <a:off x="8183880" y="5907024"/>
-            <a:ext cx="3355848" cy="420624"/>
-          </a:xfrm>
-          <a:prstGeom prst="rect">
-            <a:avLst/>
-          </a:prstGeom>
-          <a:noFill/>
-          <a:ln/>
-        </p:spPr>
-        <p:txBody>
-          <a:bodyPr wrap="square" lIns="0" tIns="0" rIns="0" bIns="0" rtlCol="0" anchor="ctr"/>
-          <a:lstStyle/>
-          <a:p>
-            <a:pPr algn="r" indent="0" marL="0">
+            <a:off x="7818120" y="5907024"/>
+            <a:ext cx="3721608" cy="420624"/>
+          </a:xfrm>
+          <a:prstGeom prst="rect">
+            <a:avLst/>
+          </a:prstGeom>
+          <a:noFill/>
+          <a:ln/>
+        </p:spPr>
+        <p:txBody>
+          <a:bodyPr wrap="square" lIns="0" tIns="0" rIns="0" bIns="0" rtlCol="0" anchor="ctr"/>
+          <a:lstStyle/>
+          <a:p>
+            <a:pPr marL="0" indent="0" algn="r">
               <a:buNone/>
             </a:pPr>
             <a:r>
@@ -7367,4 +7285,319 @@
     </a:ext>
   </a:extLst>
 </a:theme>
+</file>
+
+<file path=ppt/theme/theme2.xml><?xml version="1.0" encoding="utf-8"?>
+<a:theme xmlns:a="http://schemas.openxmlformats.org/drawingml/2006/main" name="Office Theme">
+  <a:themeElements>
+    <a:clrScheme name="Office">
+      <a:dk1>
+        <a:sysClr val="windowText" lastClr="000000"/>
+      </a:dk1>
+      <a:lt1>
+        <a:sysClr val="window" lastClr="FFFFFF"/>
+      </a:lt1>
+      <a:dk2>
+        <a:srgbClr val="0E2841"/>
+      </a:dk2>
+      <a:lt2>
+        <a:srgbClr val="E8E8E8"/>
+      </a:lt2>
+      <a:accent1>
+        <a:srgbClr val="156082"/>
+      </a:accent1>
+      <a:accent2>
+        <a:srgbClr val="E97132"/>
+      </a:accent2>
+      <a:accent3>
+        <a:srgbClr val="196B24"/>
+      </a:accent3>
+      <a:accent4>
+        <a:srgbClr val="0F9ED5"/>
+      </a:accent4>
+      <a:accent5>
+        <a:srgbClr val="A02B93"/>
+      </a:accent5>
+      <a:accent6>
+        <a:srgbClr val="4EA72E"/>
+      </a:accent6>
+      <a:hlink>
+        <a:srgbClr val="467886"/>
+      </a:hlink>
+      <a:folHlink>
+        <a:srgbClr val="96607D"/>
+      </a:folHlink>
+    </a:clrScheme>
+    <a:fontScheme name="Office">
+      <a:majorFont>
+        <a:latin typeface="Aptos Display" panose="02110004020202020204"/>
+        <a:ea typeface=""/>
+        <a:cs typeface=""/>
+        <a:font script="Jpan" typeface="游ゴシック Light"/>
+        <a:font script="Hang" typeface="맑은 고딕"/>
+        <a:font script="Hans" typeface="等线 Light"/>
+        <a:font script="Hant" typeface="新細明體"/>
+        <a:font script="Arab" typeface="Times New Roman"/>
+        <a:font script="Hebr" typeface="Times New Roman"/>
+        <a:font script="Thai" typeface="Angsana New"/>
+        <a:font script="Ethi" typeface="Nyala"/>
+        <a:font script="Beng" typeface="Vrinda"/>
+        <a:font script="Gujr" typeface="Shruti"/>
+        <a:font script="Khmr" typeface="MoolBoran"/>
+        <a:font script="Knda" typeface="Tunga"/>
+        <a:font script="Guru" typeface="Raavi"/>
+        <a:font script="Cans" typeface="Euphemia"/>
+        <a:font script="Cher" typeface="Plantagenet Cherokee"/>
+        <a:font script="Yiii" typeface="Microsoft Yi Baiti"/>
+        <a:font script="Tibt" typeface="Microsoft Himalaya"/>
+        <a:font script="Thaa" typeface="MV Boli"/>
+        <a:font script="Deva" typeface="Mangal"/>
+        <a:font script="Telu" typeface="Gautami"/>
+        <a:font script="Taml" typeface="Latha"/>
+        <a:font script="Syrc" typeface="Estrangelo Edessa"/>
+        <a:font script="Orya" typeface="Kalinga"/>
+        <a:font script="Mlym" typeface="Kartika"/>
+        <a:font script="Laoo" typeface="DokChampa"/>
+        <a:font script="Sinh" typeface="Iskoola Pota"/>
+        <a:font script="Mong" typeface="Mongolian Baiti"/>
+        <a:font script="Viet" typeface="Times New Roman"/>
+        <a:font script="Uigh" typeface="Microsoft Uighur"/>
+        <a:font script="Geor" typeface="Sylfaen"/>
+        <a:font script="Armn" typeface="Arial"/>
+        <a:font script="Bugi" typeface="Leelawadee UI"/>
+        <a:font script="Bopo" typeface="Microsoft JhengHei"/>
+        <a:font script="Java" typeface="Javanese Text"/>
+        <a:font script="Lisu" typeface="Segoe UI"/>
+        <a:font script="Mymr" typeface="Myanmar Text"/>
+        <a:font script="Nkoo" typeface="Ebrima"/>
+        <a:font script="Olck" typeface="Nirmala UI"/>
+        <a:font script="Osma" typeface="Ebrima"/>
+        <a:font script="Phag" typeface="Phagspa"/>
+        <a:font script="Syrn" typeface="Estrangelo Edessa"/>
+        <a:font script="Syrj" typeface="Estrangelo Edessa"/>
+        <a:font script="Syre" typeface="Estrangelo Edessa"/>
+        <a:font script="Sora" typeface="Nirmala UI"/>
+        <a:font script="Tale" typeface="Microsoft Tai Le"/>
+        <a:font script="Talu" typeface="Microsoft New Tai Lue"/>
+        <a:font script="Tfng" typeface="Ebrima"/>
+      </a:majorFont>
+      <a:minorFont>
+        <a:latin typeface="Aptos" panose="02110004020202020204"/>
+        <a:ea typeface=""/>
+        <a:cs typeface=""/>
+        <a:font script="Jpan" typeface="游ゴシック"/>
+        <a:font script="Hang" typeface="맑은 고딕"/>
+        <a:font script="Hans" typeface="等线"/>
+        <a:font script="Hant" typeface="新細明體"/>
+        <a:font script="Arab" typeface="Arial"/>
+        <a:font script="Hebr" typeface="Arial"/>
+        <a:font script="Thai" typeface="Cordia New"/>
+        <a:font script="Ethi" typeface="Nyala"/>
+        <a:font script="Beng" typeface="Vrinda"/>
+        <a:font script="Gujr" typeface="Shruti"/>
+        <a:font script="Khmr" typeface="DaunPenh"/>
+        <a:font script="Knda" typeface="Tunga"/>
+        <a:font script="Guru" typeface="Raavi"/>
+        <a:font script="Cans" typeface="Euphemia"/>
+        <a:font script="Cher" typeface="Plantagenet Cherokee"/>
+        <a:font script="Yiii" typeface="Microsoft Yi Baiti"/>
+        <a:font script="Tibt" typeface="Microsoft Himalaya"/>
+        <a:font script="Thaa" typeface="MV Boli"/>
+        <a:font script="Deva" typeface="Mangal"/>
+        <a:font script="Telu" typeface="Gautami"/>
+        <a:font script="Taml" typeface="Latha"/>
+        <a:font script="Syrc" typeface="Estrangelo Edessa"/>
+        <a:font script="Orya" typeface="Kalinga"/>
+        <a:font script="Mlym" typeface="Kartika"/>
+        <a:font script="Laoo" typeface="DokChampa"/>
+        <a:font script="Sinh" typeface="Iskoola Pota"/>
+        <a:font script="Mong" typeface="Mongolian Baiti"/>
+        <a:font script="Viet" typeface="Arial"/>
+        <a:font script="Uigh" typeface="Microsoft Uighur"/>
+        <a:font script="Geor" typeface="Sylfaen"/>
+        <a:font script="Armn" typeface="Arial"/>
+        <a:font script="Bugi" typeface="Leelawadee UI"/>
+        <a:font script="Bopo" typeface="Microsoft JhengHei"/>
+        <a:font script="Java" typeface="Javanese Text"/>
+        <a:font script="Lisu" typeface="Segoe UI"/>
+        <a:font script="Mymr" typeface="Myanmar Text"/>
+        <a:font script="Nkoo" typeface="Ebrima"/>
+        <a:font script="Olck" typeface="Nirmala UI"/>
+        <a:font script="Osma" typeface="Ebrima"/>
+        <a:font script="Phag" typeface="Phagspa"/>
+        <a:font script="Syrn" typeface="Estrangelo Edessa"/>
+        <a:font script="Syrj" typeface="Estrangelo Edessa"/>
+        <a:font script="Syre" typeface="Estrangelo Edessa"/>
+        <a:font script="Sora" typeface="Nirmala UI"/>
+        <a:font script="Tale" typeface="Microsoft Tai Le"/>
+        <a:font script="Talu" typeface="Microsoft New Tai Lue"/>
+        <a:font script="Tfng" typeface="Ebrima"/>
+      </a:minorFont>
+    </a:fontScheme>
+    <a:fmtScheme name="Office">
+      <a:fillStyleLst>
+        <a:solidFill>
+          <a:schemeClr val="phClr"/>
+        </a:solidFill>
+        <a:gradFill rotWithShape="1">
+          <a:gsLst>
+            <a:gs pos="0">
+              <a:schemeClr val="phClr">
+                <a:lumMod val="110000"/>
+                <a:satMod val="105000"/>
+                <a:tint val="67000"/>
+              </a:schemeClr>
+            </a:gs>
+            <a:gs pos="50000">
+              <a:schemeClr val="phClr">
+                <a:lumMod val="105000"/>
+                <a:satMod val="103000"/>
+                <a:tint val="73000"/>
+              </a:schemeClr>
+            </a:gs>
+            <a:gs pos="100000">
+              <a:schemeClr val="phClr">
+                <a:lumMod val="105000"/>
+                <a:satMod val="109000"/>
+                <a:tint val="81000"/>
+              </a:schemeClr>
+            </a:gs>
+          </a:gsLst>
+          <a:lin ang="5400000" scaled="0"/>
+        </a:gradFill>
+        <a:gradFill rotWithShape="1">
+          <a:gsLst>
+            <a:gs pos="0">
+              <a:schemeClr val="phClr">
+                <a:satMod val="103000"/>
+                <a:lumMod val="102000"/>
+                <a:tint val="94000"/>
+              </a:schemeClr>
+            </a:gs>
+            <a:gs pos="50000">
+              <a:schemeClr val="phClr">
+                <a:satMod val="110000"/>
+                <a:lumMod val="100000"/>
+                <a:shade val="100000"/>
+              </a:schemeClr>
+            </a:gs>
+            <a:gs pos="100000">
+              <a:schemeClr val="phClr">
+                <a:lumMod val="99000"/>
+                <a:satMod val="120000"/>
+                <a:shade val="78000"/>
+              </a:schemeClr>
+            </a:gs>
+          </a:gsLst>
+          <a:lin ang="5400000" scaled="0"/>
+        </a:gradFill>
+      </a:fillStyleLst>
+      <a:lnStyleLst>
+        <a:ln w="12700" cap="flat" cmpd="sng" algn="ctr">
+          <a:solidFill>
+            <a:schemeClr val="phClr"/>
+          </a:solidFill>
+          <a:prstDash val="solid"/>
+          <a:miter lim="800000"/>
+        </a:ln>
+        <a:ln w="19050" cap="flat" cmpd="sng" algn="ctr">
+          <a:solidFill>
+            <a:schemeClr val="phClr"/>
+          </a:solidFill>
+          <a:prstDash val="solid"/>
+          <a:miter lim="800000"/>
+        </a:ln>
+        <a:ln w="25400" cap="flat" cmpd="sng" algn="ctr">
+          <a:solidFill>
+            <a:schemeClr val="phClr"/>
+          </a:solidFill>
+          <a:prstDash val="solid"/>
+          <a:miter lim="800000"/>
+        </a:ln>
+      </a:lnStyleLst>
+      <a:effectStyleLst>
+        <a:effectStyle>
+          <a:effectLst/>
+        </a:effectStyle>
+        <a:effectStyle>
+          <a:effectLst/>
+        </a:effectStyle>
+        <a:effectStyle>
+          <a:effectLst>
+            <a:outerShdw blurRad="57150" dist="19050" dir="5400000" algn="ctr" rotWithShape="0">
+              <a:srgbClr val="000000">
+                <a:alpha val="63000"/>
+              </a:srgbClr>
+            </a:outerShdw>
+          </a:effectLst>
+        </a:effectStyle>
+      </a:effectStyleLst>
+      <a:bgFillStyleLst>
+        <a:solidFill>
+          <a:schemeClr val="phClr"/>
+        </a:solidFill>
+        <a:solidFill>
+          <a:schemeClr val="phClr">
+            <a:tint val="95000"/>
+            <a:satMod val="170000"/>
+          </a:schemeClr>
+        </a:solidFill>
+        <a:gradFill rotWithShape="1">
+          <a:gsLst>
+            <a:gs pos="0">
+              <a:schemeClr val="phClr">
+                <a:tint val="93000"/>
+                <a:satMod val="150000"/>
+                <a:shade val="98000"/>
+                <a:lumMod val="102000"/>
+              </a:schemeClr>
+            </a:gs>
+            <a:gs pos="50000">
+              <a:schemeClr val="phClr">
+                <a:tint val="98000"/>
+                <a:satMod val="130000"/>
+                <a:shade val="90000"/>
+                <a:lumMod val="103000"/>
+              </a:schemeClr>
+            </a:gs>
+            <a:gs pos="100000">
+              <a:schemeClr val="phClr">
+                <a:shade val="63000"/>
+                <a:satMod val="120000"/>
+              </a:schemeClr>
+            </a:gs>
+          </a:gsLst>
+          <a:lin ang="5400000" scaled="0"/>
+        </a:gradFill>
+      </a:bgFillStyleLst>
+    </a:fmtScheme>
+  </a:themeElements>
+  <a:objectDefaults>
+    <a:lnDef>
+      <a:spPr/>
+      <a:bodyPr/>
+      <a:lstStyle/>
+      <a:style>
+        <a:lnRef idx="2">
+          <a:schemeClr val="accent1"/>
+        </a:lnRef>
+        <a:fillRef idx="0">
+          <a:schemeClr val="accent1"/>
+        </a:fillRef>
+        <a:effectRef idx="1">
+          <a:schemeClr val="accent1"/>
+        </a:effectRef>
+        <a:fontRef idx="minor">
+          <a:schemeClr val="tx1"/>
+        </a:fontRef>
+      </a:style>
+    </a:lnDef>
+  </a:objectDefaults>
+  <a:extraClrSchemeLst/>
+  <a:extLst>
+    <a:ext uri="{05A4C25C-085E-4340-85A3-A5531E510DB2}">
+      <thm15:themeFamily xmlns:thm15="http://schemas.microsoft.com/office/thememl/2012/main" name="Office Theme" id="{2E142A2C-CD16-42D6-873A-C26D2A0506FA}" vid="{1BDDFF52-6CD6-40A5-AB3C-68EB2F1E4D0A}"/>
+    </a:ext>
+  </a:extLst>
+</a:theme>
 </file>
</xml_diff>